<commit_message>
Regenerar presentacion y PDFs con los numeros corregidos
Los tres documentos citaban las cifras infladas por el baseline en frio.
Actualizados con las mediciones del metodo corregido:

- Eficiencia con 8 hilos: 85-91% -> 38-42% en las estrategias buenas,
  5-10% -> 6-10% en las que sincronizan por fila.
- Contencion del lock: 6.41s -> 10.64s con 8 hilos (44x mas que con 1).
- Conteo de pruebas: 53 -> 61.

Ademas se reemplazaron dos secciones que ya no eran validas:

- La diapositiva y la seccion sobre la mejora por Server GC pasan a
  documentar la retractacion: medida de nuevo, la mejora no existe.
- La presentacion gana una diapositiva sobre el error de medicion
  propio, con la evidencia de las diez ejecuciones consecutivas.
- La conclusion "los hilos comparten el recolector de basura" se
  reemplaza por "el techo real lo pone el hardware", que es lo que
  efectivamente muestran los datos.

Co-Authored-By: Claude Opus 5 <noreply@anthropic.com>
</commit_message>
<xml_diff>
--- a/VentasParalelo-Presentacion.pptx
+++ b/VentasParalelo-Presentacion.pptx
@@ -152,7 +152,7 @@
           </c:spPr>
           <c:invertIfNegative val="0"/>
           <c:dLbls>
-            <c:numFmt formatCode="0.00&quot;s&quot;" sourceLinked="0"/>
+            <c:numFmt formatCode="0.0&quot;s&quot;" sourceLinked="0"/>
             <c:txPr>
               <a:bodyPr/>
               <a:lstStyle/>
@@ -204,23 +204,23 @@
                 <c:formatCode>General</c:formatCode>
                 <c:ptCount val="4"/>
                 <c:pt idx="0">
-                  <c:v>0.12</c:v>
+                  <c:v>0.24</c:v>
                 </c:pt>
                 <c:pt idx="1">
-                  <c:v>0.87</c:v>
+                  <c:v>1.59</c:v>
                 </c:pt>
                 <c:pt idx="2">
-                  <c:v>2.69</c:v>
+                  <c:v>4.54</c:v>
                 </c:pt>
                 <c:pt idx="3">
-                  <c:v>6.41</c:v>
+                  <c:v>10.64</c:v>
                 </c:pt>
               </c:numCache>
             </c:numRef>
           </c:val>
         </c:ser>
         <c:dLbls>
-          <c:numFmt formatCode="0.00&quot;s&quot;" sourceLinked="0"/>
+          <c:numFmt formatCode="0.0&quot;s&quot;" sourceLinked="0"/>
           <c:txPr>
             <a:bodyPr/>
             <a:lstStyle/>
@@ -294,7 +294,7 @@
         <c:axId val="2094734552"/>
         <c:scaling>
           <c:orientation val="minMax"/>
-          <c:max val="8"/>
+          <c:max val="12"/>
         </c:scaling>
         <c:delete val="0"/>
         <c:axPos val="l"/>
@@ -549,7 +549,7 @@
                 <c:formatCode>General</c:formatCode>
                 <c:ptCount val="8"/>
                 <c:pt idx="0">
-                  <c:v>5</c:v>
+                  <c:v>6</c:v>
                 </c:pt>
                 <c:pt idx="1">
                   <c:v>8</c:v>
@@ -558,19 +558,19 @@
                   <c:v>10</c:v>
                 </c:pt>
                 <c:pt idx="3">
-                  <c:v>64</c:v>
+                  <c:v>32</c:v>
                 </c:pt>
                 <c:pt idx="4">
-                  <c:v>83</c:v>
+                  <c:v>38</c:v>
                 </c:pt>
                 <c:pt idx="5">
-                  <c:v>85</c:v>
+                  <c:v>41</c:v>
                 </c:pt>
                 <c:pt idx="6">
-                  <c:v>88</c:v>
+                  <c:v>41</c:v>
                 </c:pt>
                 <c:pt idx="7">
-                  <c:v>91</c:v>
+                  <c:v>42</c:v>
                 </c:pt>
               </c:numCache>
             </c:numRef>
@@ -651,7 +651,7 @@
         <c:axId val="2094734552"/>
         <c:scaling>
           <c:orientation val="minMax"/>
-          <c:max val="100"/>
+          <c:max val="50"/>
         </c:scaling>
         <c:delete val="0"/>
         <c:axPos val="b"/>
@@ -741,7 +741,7 @@
               <c:strCache>
                 <c:ptCount val="1"/>
                 <c:pt idx="0">
-                  <c:v>Antes  (Workstation GC)</c:v>
+                  <c:v>Workstation GC</c:v>
                 </c:pt>
               </c:strCache>
             </c:strRef>
@@ -809,19 +809,19 @@
                 <c:formatCode>General</c:formatCode>
                 <c:ptCount val="5"/>
                 <c:pt idx="0">
-                  <c:v>59</c:v>
+                  <c:v>42</c:v>
                 </c:pt>
                 <c:pt idx="1">
-                  <c:v>77</c:v>
+                  <c:v>43</c:v>
                 </c:pt>
                 <c:pt idx="2">
-                  <c:v>79</c:v>
+                  <c:v>39</c:v>
                 </c:pt>
                 <c:pt idx="3">
-                  <c:v>75</c:v>
+                  <c:v>39</c:v>
                 </c:pt>
                 <c:pt idx="4">
-                  <c:v>53</c:v>
+                  <c:v>29</c:v>
                 </c:pt>
               </c:numCache>
             </c:numRef>
@@ -836,7 +836,7 @@
               <c:strCache>
                 <c:ptCount val="1"/>
                 <c:pt idx="0">
-                  <c:v>Después  (Server GC)</c:v>
+                  <c:v>Server GC</c:v>
                 </c:pt>
               </c:strCache>
             </c:strRef>
@@ -904,19 +904,19 @@
                 <c:formatCode>General</c:formatCode>
                 <c:ptCount val="5"/>
                 <c:pt idx="0">
-                  <c:v>91</c:v>
+                  <c:v>41</c:v>
                 </c:pt>
                 <c:pt idx="1">
-                  <c:v>88</c:v>
+                  <c:v>38</c:v>
                 </c:pt>
                 <c:pt idx="2">
-                  <c:v>85</c:v>
+                  <c:v>35</c:v>
                 </c:pt>
                 <c:pt idx="3">
-                  <c:v>83</c:v>
+                  <c:v>40</c:v>
                 </c:pt>
                 <c:pt idx="4">
-                  <c:v>64</c:v>
+                  <c:v>29</c:v>
                 </c:pt>
               </c:numCache>
             </c:numRef>
@@ -997,7 +997,7 @@
         <c:axId val="2094734552"/>
         <c:scaling>
           <c:orientation val="minMax"/>
-          <c:max val="100"/>
+          <c:max val="50"/>
         </c:scaling>
         <c:delete val="0"/>
         <c:axPos val="l"/>
@@ -2168,7 +2168,7 @@
           <a:p>
             <a:r>
               <a:rPr lang="en-US" dirty="0"/>
-              <a:t>Enfatizar el punto 3: de nada sirve que una estrategia sea rapida si da un resultado distinto. Por eso hay 53 pruebas que verifican que TODAS las estrategias producen exactamente los mismos totales que el baseline secuencial. Sin eso, comparar tiempos no significa nada.</a:t>
+              <a:t>Enfatizar el punto 3: de nada sirve que una estrategia sea rapida si da un resultado distinto. Por eso hay 61 pruebas que verifican que TODAS las estrategias producen exactamente los mismos totales que el baseline secuencial. Sin eso, comparar tiempos no significa nada.</a:t>
             </a:r>
             <a:endParaRPr lang="en-US" dirty="0"/>
           </a:p>
@@ -2608,7 +2608,7 @@
           <a:p>
             <a:r>
               <a:rPr lang="en-US" dirty="0"/>
-              <a:t>Senalar la fila 1: 6.84 en la primera corrida, 6.00 en la tercera. Esa variacion dentro de la MISMA estrategia es mas grande que la distancia entre las tres primeras estrategias. Por eso no se puede declarar un ganador entre ellas. Round-robin si es distinguible porque queda fuera de ese rango en las tres corridas.</a:t>
+              <a:t>Este es el momento mas importante de la presentacion. El proyecto no solo midio: se audito a si mismo y encontro que su propia herramienta estaba mal calibrada. La pista fue una cifra que no podia existir — eficiencia mayor al 100% con un solo hilo. Sin repetir las mediciones, ese error no habria aparecido nunca.</a:t>
             </a:r>
             <a:endParaRPr lang="en-US" dirty="0"/>
           </a:p>
@@ -2696,7 +2696,7 @@
           <a:p>
             <a:r>
               <a:rPr lang="en-US" dirty="0"/>
-              <a:t>Esta diapositiva responde la pregunta '¿los hilos son realmente independientes?'. La respuesta es que no del todo: comparten el heap de .NET. Es una linea de configuracion, cero cambios en los algoritmos, y mejora las cinco estrategias a la vez. La leccion: no toda la contencion esta en el codigo que uno escribe.</a:t>
+              <a:t>Explicar la diferencia entre lo que se cayo y lo que se sostuvo. Los valores absolutos estaban inflados y la mejora por Server GC era pura ilusion; pero la comparacion ENTRE estrategias seguia siendo valida, porque todas se dividian entre el mismo baseline malo y el error se cancelaba. Esa distincion es la parte fina del analisis.</a:t>
             </a:r>
             <a:endParaRPr lang="en-US" dirty="0"/>
           </a:p>
@@ -4367,7 +4367,7 @@
                 <a:ea typeface="Calibri" pitchFamily="34" charset="-122"/>
                 <a:cs typeface="Calibri" pitchFamily="34" charset="-120"/>
               </a:rPr>
-              <a:t>Sincronizar en cada fila da 5–10 % de eficiencia; hacerlo una vez por partición da 64–91 %. Un orden de magnitud, con el mismo número de hilos.</a:t>
+              <a:t>Sincronizar en cada fila da 6–10 % de eficiencia; hacerlo una vez por partición da 32–42 %. Entre 4 y 7 veces mejor, con el mismo número de hilos.</a:t>
             </a:r>
             <a:endParaRPr lang="en-US" sz="1250" dirty="0"/>
           </a:p>
@@ -4507,7 +4507,7 @@
                 <a:ea typeface="Calibri" pitchFamily="34" charset="-122"/>
                 <a:cs typeface="Calibri" pitchFamily="34" charset="-120"/>
               </a:rPr>
-              <a:t>Los hilos nunca son del todo independientes</a:t>
+              <a:t>El techo real lo pone el hardware</a:t>
             </a:r>
             <a:endParaRPr lang="en-US" sz="1500" dirty="0"/>
           </a:p>
@@ -4549,7 +4549,7 @@
                 <a:ea typeface="Calibri" pitchFamily="34" charset="-122"/>
                 <a:cs typeface="Calibri" pitchFamily="34" charset="-120"/>
               </a:rPr>
-              <a:t>Aunque el código no tenga un solo lock, comparten el recolector de basura, la caché y los núcleos físicos. Ahí estaba escondida parte de la pérdida.</a:t>
+              <a:t>Sin sincronización por fila, las cinco variantes rinden casi igual y todas se estancan cerca del 40 % con 8 hilos: son 4 núcleos físicos y, en datasets grandes, el ancho de banda de memoria.</a:t>
             </a:r>
             <a:endParaRPr lang="en-US" sz="1250" dirty="0"/>
           </a:p>
@@ -5307,7 +5307,7 @@
                 <a:ea typeface="Cambria" pitchFamily="34" charset="-122"/>
                 <a:cs typeface="Cambria" pitchFamily="34" charset="-120"/>
               </a:rPr>
-              <a:t>53</a:t>
+              <a:t>61</a:t>
             </a:r>
             <a:endParaRPr lang="en-US" sz="2600" dirty="0"/>
           </a:p>
@@ -5349,7 +5349,7 @@
                 <a:ea typeface="Calibri" pitchFamily="34" charset="-122"/>
                 <a:cs typeface="Calibri" pitchFamily="34" charset="-120"/>
               </a:rPr>
-              <a:t>pruebas unitarias de correctitud</a:t>
+              <a:t>pruebas unitarias</a:t>
             </a:r>
             <a:endParaRPr lang="en-US" sz="1200" dirty="0"/>
           </a:p>
@@ -5469,7 +5469,7 @@
                 <a:ea typeface="Cambria" pitchFamily="34" charset="-122"/>
                 <a:cs typeface="Cambria" pitchFamily="34" charset="-120"/>
               </a:rPr>
-              <a:t>91 %</a:t>
+              <a:t>42 %</a:t>
             </a:r>
             <a:endParaRPr lang="en-US" sz="2600" dirty="0"/>
           </a:p>
@@ -7082,7 +7082,7 @@
                 <a:ea typeface="Calibri" pitchFamily="34" charset="-122"/>
                 <a:cs typeface="Calibri" pitchFamily="34" charset="-120"/>
               </a:rPr>
-              <a:t>53 pruebas unitarias comprueban que toda estrategia paralela produce exactamente los mismos totales que el baseline secuencial.</a:t>
+              <a:t>61 pruebas unitarias comprueban que toda estrategia paralela produce exactamente los mismos totales que el baseline secuencial.</a:t>
             </a:r>
             <a:endParaRPr lang="en-US" sz="1300" dirty="0"/>
           </a:p>
@@ -8556,7 +8556,7 @@
                 <a:ea typeface="Cambria" pitchFamily="34" charset="-122"/>
                 <a:cs typeface="Cambria" pitchFamily="34" charset="-120"/>
               </a:rPr>
-              <a:t>53×</a:t>
+              <a:t>44×</a:t>
             </a:r>
             <a:endParaRPr lang="en-US" sz="6000" dirty="0"/>
           </a:p>
@@ -8640,7 +8640,7 @@
                 <a:ea typeface="Calibri" pitchFamily="34" charset="-122"/>
                 <a:cs typeface="Calibri" pitchFamily="34" charset="-120"/>
               </a:rPr>
-              <a:t>Con 8 hilos, la espera acumulada (6.41 s) supera el tiempo total de la corrida: casi todo el paralelismo se gasta en hacer cola, no en trabajar.</a:t>
+              <a:t>Con 8 hilos, la espera acumulada (10.6 s) supera el tiempo total de la corrida: casi todo el paralelismo se gasta en hacer cola, no en trabajar.</a:t>
             </a:r>
             <a:endParaRPr lang="en-US" sz="1250" dirty="0"/>
           </a:p>
@@ -8805,7 +8805,7 @@
                 <a:ea typeface="Calibri" pitchFamily="34" charset="-122"/>
                 <a:cs typeface="Calibri" pitchFamily="34" charset="-120"/>
               </a:rPr>
-              <a:t>Promedio de 3 corridas · 5 millones de filas · Release · configuración final</a:t>
+              <a:t>Promedio de 3 corridas · 5 M de filas · Release · con calentamiento global</a:t>
             </a:r>
             <a:endParaRPr lang="en-US" sz="1100" dirty="0"/>
           </a:p>
@@ -8878,7 +8878,7 @@
                 <a:ea typeface="Cambria" pitchFamily="34" charset="-122"/>
                 <a:cs typeface="Cambria" pitchFamily="34" charset="-120"/>
               </a:rPr>
-              <a:t>5 – 10 %</a:t>
+              <a:t>6 – 10 %</a:t>
             </a:r>
             <a:endParaRPr lang="en-US" sz="2800" dirty="0"/>
           </a:p>
@@ -9032,7 +9032,7 @@
                 <a:ea typeface="Cambria" pitchFamily="34" charset="-122"/>
                 <a:cs typeface="Cambria" pitchFamily="34" charset="-120"/>
               </a:rPr>
-              <a:t>64 – 91 %</a:t>
+              <a:t>32 – 42 %</a:t>
             </a:r>
             <a:endParaRPr lang="en-US" sz="2800" dirty="0"/>
           </a:p>
@@ -9113,7 +9113,7 @@
                 <a:ea typeface="Calibri" pitchFamily="34" charset="-122"/>
                 <a:cs typeface="Calibri" pitchFamily="34" charset="-120"/>
               </a:rPr>
-              <a:t>Un orden de magnitud de diferencia. Es la conclusión central del proyecto.</a:t>
+              <a:t>Entre 4 y 7 veces mejor, con los mismos hilos. Es la conclusión central del proyecto.</a:t>
             </a:r>
             <a:endParaRPr lang="en-US" sz="1150" dirty="0"/>
           </a:p>
@@ -10043,13 +10043,13 @@
             <a:r>
               <a:rPr lang="en-US" sz="1200" b="1" spc="200" kern="0" dirty="0">
                 <a:solidFill>
-                  <a:srgbClr val="00A896"/>
-                </a:solidFill>
-                <a:latin typeface="Calibri" pitchFamily="34" charset="0"/>
-                <a:ea typeface="Calibri" pitchFamily="34" charset="-122"/>
-                <a:cs typeface="Calibri" pitchFamily="34" charset="-120"/>
-              </a:rPr>
-              <a:t>LA CORRECCIÓN</a:t>
+                  <a:srgbClr val="E94F4F"/>
+                </a:solidFill>
+                <a:latin typeface="Calibri" pitchFamily="34" charset="0"/>
+                <a:ea typeface="Calibri" pitchFamily="34" charset="-122"/>
+                <a:cs typeface="Calibri" pitchFamily="34" charset="-120"/>
+              </a:rPr>
+              <a:t>EL ERROR MÁS GRANDE</a:t>
             </a:r>
             <a:endParaRPr lang="en-US" sz="1200" dirty="0"/>
           </a:p>
@@ -10088,7 +10088,7 @@
                 <a:ea typeface="Cambria" pitchFamily="34" charset="-122"/>
                 <a:cs typeface="Cambria" pitchFamily="34" charset="-120"/>
               </a:rPr>
-              <a:t>Repetir la medición cambió la conclusión</a:t>
+              <a:t>Nuestras propias mediciones estaban mal</a:t>
             </a:r>
             <a:endParaRPr lang="en-US" sz="3800" dirty="0"/>
           </a:p>
@@ -10103,19 +10103,22 @@
         <p:spPr>
           <a:xfrm>
             <a:off x="658368" y="1170432"/>
-            <a:ext cx="10881360" cy="320040"/>
-          </a:xfrm>
-          <a:prstGeom prst="rect">
-            <a:avLst/>
-          </a:prstGeom>
-          <a:noFill/>
-          <a:ln/>
-        </p:spPr>
-        <p:txBody>
-          <a:bodyPr wrap="square" lIns="0" tIns="0" rIns="0" bIns="0" rtlCol="0" anchor="ctr"/>
-          <a:lstStyle/>
-          <a:p>
-            <a:pPr indent="0" marL="0">
+            <a:ext cx="6949440" cy="822960"/>
+          </a:xfrm>
+          <a:prstGeom prst="rect">
+            <a:avLst/>
+          </a:prstGeom>
+          <a:noFill/>
+          <a:ln/>
+        </p:spPr>
+        <p:txBody>
+          <a:bodyPr wrap="square" lIns="0" tIns="0" rIns="0" bIns="0" rtlCol="0" anchor="ctr"/>
+          <a:lstStyle/>
+          <a:p>
+            <a:pPr indent="0" marL="0">
+              <a:lnSpc>
+                <a:spcPts val="2000"/>
+              </a:lnSpc>
               <a:buNone/>
             </a:pPr>
             <a:r>
@@ -10127,1765 +10130,524 @@
                 <a:ea typeface="Calibri" pitchFamily="34" charset="-122"/>
                 <a:cs typeface="Calibri" pitchFamily="34" charset="-120"/>
               </a:rPr>
-              <a:t>Misma máquina, mismo binario, sin tocar el código entre corridas. Speedup con 8 hilos:</a:t>
+              <a:t>La tabla reportaba eficiencias imposibles: 187 % con 2 hilos y 172 % con un solo hilo. Ninguna estrategia puede superar el 100 % con 1 hilo — hace el mismo trabajo que la secuencial más el overhead de particionar.</a:t>
             </a:r>
             <a:endParaRPr lang="en-US" sz="1400" dirty="0"/>
           </a:p>
         </p:txBody>
       </p:sp>
-      <p:graphicFrame>
-        <p:nvGraphicFramePr>
-          <p:cNvPr id="9" name="Table 0"/>
-          <p:cNvGraphicFramePr>
-            <a:graphicFrameLocks noGrp="1"/>
-          </p:cNvGraphicFramePr>
-          <p:nvPr>
-            <p:extLst>
-              <p:ext uri="{D42A27DB-BD31-4B8C-83A1-F6EECF244321}">
-                <p14:modId xmlns:p14="http://schemas.microsoft.com/office/powerpoint/2010/main" val="1579011935"/>
-              </p:ext>
-            </p:extLst>
-          </p:nvPr>
-        </p:nvGraphicFramePr>
-        <p:xfrm>
-          <a:off x="640080" y="1627632"/>
-          <a:ext cx="6949440" cy="914400"/>
-        </p:xfrm>
-        <a:graphic>
-          <a:graphicData uri="http://schemas.openxmlformats.org/drawingml/2006/table">
-            <a:tbl>
-              <a:tblPr/>
-              <a:tblGrid>
-                <a:gridCol w="2377440"/>
-                <a:gridCol w="1143000"/>
-                <a:gridCol w="1143000"/>
-                <a:gridCol w="1143000"/>
-                <a:gridCol w="1143000"/>
-              </a:tblGrid>
-              <a:tr h="420624">
-                <a:tc>
-                  <a:txBody>
-                    <a:bodyPr/>
-                    <a:lstStyle/>
-                    <a:p>
-                      <a:pPr algn="l" indent="0" marL="0">
-                        <a:buNone/>
-                      </a:pPr>
-                      <a:r>
-                        <a:rPr lang="en-US" sz="1300" b="1" dirty="0">
-                          <a:solidFill>
-                            <a:srgbClr val="FFFFFF"/>
-                          </a:solidFill>
-                          <a:latin typeface="Calibri" pitchFamily="34" charset="0"/>
-                          <a:ea typeface="Calibri" pitchFamily="34" charset="-122"/>
-                          <a:cs typeface="Calibri" pitchFamily="34" charset="-120"/>
-                        </a:rPr>
-                        <a:t>Estrategia</a:t>
-                      </a:r>
-                      <a:endParaRPr lang="en-US" sz="1300" dirty="0">
-                        <a:latin typeface="Calibri" charset="0"/>
-                        <a:ea typeface="Calibri" charset="0"/>
-                        <a:cs typeface="Calibri" charset="0"/>
-                      </a:endParaRPr>
-                    </a:p>
-                  </a:txBody>
-                  <a:tcPr marL="91440" marR="91440" marT="45720" marB="45720" anchor="ctr">
-                    <a:lnL w="12700" cap="flat" cmpd="sng" algn="ctr">
-                      <a:solidFill>
-                        <a:srgbClr val="E3E8EC"/>
-                      </a:solidFill>
-                      <a:prstDash val="solid"/>
-                      <a:round/>
-                      <a:headEnd type="none" w="med" len="med"/>
-                      <a:tailEnd type="none" w="med" len="med"/>
-                    </a:lnL>
-                    <a:lnR w="12700" cap="flat" cmpd="sng" algn="ctr">
-                      <a:solidFill>
-                        <a:srgbClr val="E3E8EC"/>
-                      </a:solidFill>
-                      <a:prstDash val="solid"/>
-                      <a:round/>
-                      <a:headEnd type="none" w="med" len="med"/>
-                      <a:tailEnd type="none" w="med" len="med"/>
-                    </a:lnR>
-                    <a:lnT w="12700" cap="flat" cmpd="sng" algn="ctr">
-                      <a:solidFill>
-                        <a:srgbClr val="E3E8EC"/>
-                      </a:solidFill>
-                      <a:prstDash val="solid"/>
-                      <a:round/>
-                      <a:headEnd type="none" w="med" len="med"/>
-                      <a:tailEnd type="none" w="med" len="med"/>
-                    </a:lnT>
-                    <a:lnB w="12700" cap="flat" cmpd="sng" algn="ctr">
-                      <a:solidFill>
-                        <a:srgbClr val="E3E8EC"/>
-                      </a:solidFill>
-                      <a:prstDash val="solid"/>
-                      <a:round/>
-                      <a:headEnd type="none" w="med" len="med"/>
-                      <a:tailEnd type="none" w="med" len="med"/>
-                    </a:lnB>
-                    <a:solidFill>
-                      <a:srgbClr val="14202E"/>
-                    </a:solidFill>
-                  </a:tcPr>
-                </a:tc>
-                <a:tc>
-                  <a:txBody>
-                    <a:bodyPr/>
-                    <a:lstStyle/>
-                    <a:p>
-                      <a:pPr algn="ctr" indent="0" marL="0">
-                        <a:buNone/>
-                      </a:pPr>
-                      <a:r>
-                        <a:rPr lang="en-US" sz="1300" b="1" dirty="0">
-                          <a:solidFill>
-                            <a:srgbClr val="FFFFFF"/>
-                          </a:solidFill>
-                          <a:latin typeface="Calibri" pitchFamily="34" charset="0"/>
-                          <a:ea typeface="Calibri" pitchFamily="34" charset="-122"/>
-                          <a:cs typeface="Calibri" pitchFamily="34" charset="-120"/>
-                        </a:rPr>
-                        <a:t>Corrida 1</a:t>
-                      </a:r>
-                      <a:endParaRPr lang="en-US" sz="1300" dirty="0">
-                        <a:latin typeface="Calibri" charset="0"/>
-                        <a:ea typeface="Calibri" charset="0"/>
-                        <a:cs typeface="Calibri" charset="0"/>
-                      </a:endParaRPr>
-                    </a:p>
-                  </a:txBody>
-                  <a:tcPr marL="91440" marR="91440" marT="45720" marB="45720" anchor="ctr">
-                    <a:lnL w="12700" cap="flat" cmpd="sng" algn="ctr">
-                      <a:solidFill>
-                        <a:srgbClr val="E3E8EC"/>
-                      </a:solidFill>
-                      <a:prstDash val="solid"/>
-                      <a:round/>
-                      <a:headEnd type="none" w="med" len="med"/>
-                      <a:tailEnd type="none" w="med" len="med"/>
-                    </a:lnL>
-                    <a:lnR w="12700" cap="flat" cmpd="sng" algn="ctr">
-                      <a:solidFill>
-                        <a:srgbClr val="E3E8EC"/>
-                      </a:solidFill>
-                      <a:prstDash val="solid"/>
-                      <a:round/>
-                      <a:headEnd type="none" w="med" len="med"/>
-                      <a:tailEnd type="none" w="med" len="med"/>
-                    </a:lnR>
-                    <a:lnT w="12700" cap="flat" cmpd="sng" algn="ctr">
-                      <a:solidFill>
-                        <a:srgbClr val="E3E8EC"/>
-                      </a:solidFill>
-                      <a:prstDash val="solid"/>
-                      <a:round/>
-                      <a:headEnd type="none" w="med" len="med"/>
-                      <a:tailEnd type="none" w="med" len="med"/>
-                    </a:lnT>
-                    <a:lnB w="12700" cap="flat" cmpd="sng" algn="ctr">
-                      <a:solidFill>
-                        <a:srgbClr val="E3E8EC"/>
-                      </a:solidFill>
-                      <a:prstDash val="solid"/>
-                      <a:round/>
-                      <a:headEnd type="none" w="med" len="med"/>
-                      <a:tailEnd type="none" w="med" len="med"/>
-                    </a:lnB>
-                    <a:solidFill>
-                      <a:srgbClr val="14202E"/>
-                    </a:solidFill>
-                  </a:tcPr>
-                </a:tc>
-                <a:tc>
-                  <a:txBody>
-                    <a:bodyPr/>
-                    <a:lstStyle/>
-                    <a:p>
-                      <a:pPr algn="ctr" indent="0" marL="0">
-                        <a:buNone/>
-                      </a:pPr>
-                      <a:r>
-                        <a:rPr lang="en-US" sz="1300" b="1" dirty="0">
-                          <a:solidFill>
-                            <a:srgbClr val="FFFFFF"/>
-                          </a:solidFill>
-                          <a:latin typeface="Calibri" pitchFamily="34" charset="0"/>
-                          <a:ea typeface="Calibri" pitchFamily="34" charset="-122"/>
-                          <a:cs typeface="Calibri" pitchFamily="34" charset="-120"/>
-                        </a:rPr>
-                        <a:t>Corrida 2</a:t>
-                      </a:r>
-                      <a:endParaRPr lang="en-US" sz="1300" dirty="0">
-                        <a:latin typeface="Calibri" charset="0"/>
-                        <a:ea typeface="Calibri" charset="0"/>
-                        <a:cs typeface="Calibri" charset="0"/>
-                      </a:endParaRPr>
-                    </a:p>
-                  </a:txBody>
-                  <a:tcPr marL="91440" marR="91440" marT="45720" marB="45720" anchor="ctr">
-                    <a:lnL w="12700" cap="flat" cmpd="sng" algn="ctr">
-                      <a:solidFill>
-                        <a:srgbClr val="E3E8EC"/>
-                      </a:solidFill>
-                      <a:prstDash val="solid"/>
-                      <a:round/>
-                      <a:headEnd type="none" w="med" len="med"/>
-                      <a:tailEnd type="none" w="med" len="med"/>
-                    </a:lnL>
-                    <a:lnR w="12700" cap="flat" cmpd="sng" algn="ctr">
-                      <a:solidFill>
-                        <a:srgbClr val="E3E8EC"/>
-                      </a:solidFill>
-                      <a:prstDash val="solid"/>
-                      <a:round/>
-                      <a:headEnd type="none" w="med" len="med"/>
-                      <a:tailEnd type="none" w="med" len="med"/>
-                    </a:lnR>
-                    <a:lnT w="12700" cap="flat" cmpd="sng" algn="ctr">
-                      <a:solidFill>
-                        <a:srgbClr val="E3E8EC"/>
-                      </a:solidFill>
-                      <a:prstDash val="solid"/>
-                      <a:round/>
-                      <a:headEnd type="none" w="med" len="med"/>
-                      <a:tailEnd type="none" w="med" len="med"/>
-                    </a:lnT>
-                    <a:lnB w="12700" cap="flat" cmpd="sng" algn="ctr">
-                      <a:solidFill>
-                        <a:srgbClr val="E3E8EC"/>
-                      </a:solidFill>
-                      <a:prstDash val="solid"/>
-                      <a:round/>
-                      <a:headEnd type="none" w="med" len="med"/>
-                      <a:tailEnd type="none" w="med" len="med"/>
-                    </a:lnB>
-                    <a:solidFill>
-                      <a:srgbClr val="14202E"/>
-                    </a:solidFill>
-                  </a:tcPr>
-                </a:tc>
-                <a:tc>
-                  <a:txBody>
-                    <a:bodyPr/>
-                    <a:lstStyle/>
-                    <a:p>
-                      <a:pPr algn="ctr" indent="0" marL="0">
-                        <a:buNone/>
-                      </a:pPr>
-                      <a:r>
-                        <a:rPr lang="en-US" sz="1300" b="1" dirty="0">
-                          <a:solidFill>
-                            <a:srgbClr val="FFFFFF"/>
-                          </a:solidFill>
-                          <a:latin typeface="Calibri" pitchFamily="34" charset="0"/>
-                          <a:ea typeface="Calibri" pitchFamily="34" charset="-122"/>
-                          <a:cs typeface="Calibri" pitchFamily="34" charset="-120"/>
-                        </a:rPr>
-                        <a:t>Corrida 3</a:t>
-                      </a:r>
-                      <a:endParaRPr lang="en-US" sz="1300" dirty="0">
-                        <a:latin typeface="Calibri" charset="0"/>
-                        <a:ea typeface="Calibri" charset="0"/>
-                        <a:cs typeface="Calibri" charset="0"/>
-                      </a:endParaRPr>
-                    </a:p>
-                  </a:txBody>
-                  <a:tcPr marL="91440" marR="91440" marT="45720" marB="45720" anchor="ctr">
-                    <a:lnL w="12700" cap="flat" cmpd="sng" algn="ctr">
-                      <a:solidFill>
-                        <a:srgbClr val="E3E8EC"/>
-                      </a:solidFill>
-                      <a:prstDash val="solid"/>
-                      <a:round/>
-                      <a:headEnd type="none" w="med" len="med"/>
-                      <a:tailEnd type="none" w="med" len="med"/>
-                    </a:lnL>
-                    <a:lnR w="12700" cap="flat" cmpd="sng" algn="ctr">
-                      <a:solidFill>
-                        <a:srgbClr val="E3E8EC"/>
-                      </a:solidFill>
-                      <a:prstDash val="solid"/>
-                      <a:round/>
-                      <a:headEnd type="none" w="med" len="med"/>
-                      <a:tailEnd type="none" w="med" len="med"/>
-                    </a:lnR>
-                    <a:lnT w="12700" cap="flat" cmpd="sng" algn="ctr">
-                      <a:solidFill>
-                        <a:srgbClr val="E3E8EC"/>
-                      </a:solidFill>
-                      <a:prstDash val="solid"/>
-                      <a:round/>
-                      <a:headEnd type="none" w="med" len="med"/>
-                      <a:tailEnd type="none" w="med" len="med"/>
-                    </a:lnT>
-                    <a:lnB w="12700" cap="flat" cmpd="sng" algn="ctr">
-                      <a:solidFill>
-                        <a:srgbClr val="E3E8EC"/>
-                      </a:solidFill>
-                      <a:prstDash val="solid"/>
-                      <a:round/>
-                      <a:headEnd type="none" w="med" len="med"/>
-                      <a:tailEnd type="none" w="med" len="med"/>
-                    </a:lnB>
-                    <a:solidFill>
-                      <a:srgbClr val="14202E"/>
-                    </a:solidFill>
-                  </a:tcPr>
-                </a:tc>
-                <a:tc>
-                  <a:txBody>
-                    <a:bodyPr/>
-                    <a:lstStyle/>
-                    <a:p>
-                      <a:pPr algn="ctr" indent="0" marL="0">
-                        <a:buNone/>
-                      </a:pPr>
-                      <a:r>
-                        <a:rPr lang="en-US" sz="1300" b="1" dirty="0">
-                          <a:solidFill>
-                            <a:srgbClr val="FFFFFF"/>
-                          </a:solidFill>
-                          <a:latin typeface="Calibri" pitchFamily="34" charset="0"/>
-                          <a:ea typeface="Calibri" pitchFamily="34" charset="-122"/>
-                          <a:cs typeface="Calibri" pitchFamily="34" charset="-120"/>
-                        </a:rPr>
-                        <a:t>Promedio</a:t>
-                      </a:r>
-                      <a:endParaRPr lang="en-US" sz="1300" dirty="0">
-                        <a:latin typeface="Calibri" charset="0"/>
-                        <a:ea typeface="Calibri" charset="0"/>
-                        <a:cs typeface="Calibri" charset="0"/>
-                      </a:endParaRPr>
-                    </a:p>
-                  </a:txBody>
-                  <a:tcPr marL="91440" marR="91440" marT="45720" marB="45720" anchor="ctr">
-                    <a:lnL w="12700" cap="flat" cmpd="sng" algn="ctr">
-                      <a:solidFill>
-                        <a:srgbClr val="E3E8EC"/>
-                      </a:solidFill>
-                      <a:prstDash val="solid"/>
-                      <a:round/>
-                      <a:headEnd type="none" w="med" len="med"/>
-                      <a:tailEnd type="none" w="med" len="med"/>
-                    </a:lnL>
-                    <a:lnR w="12700" cap="flat" cmpd="sng" algn="ctr">
-                      <a:solidFill>
-                        <a:srgbClr val="E3E8EC"/>
-                      </a:solidFill>
-                      <a:prstDash val="solid"/>
-                      <a:round/>
-                      <a:headEnd type="none" w="med" len="med"/>
-                      <a:tailEnd type="none" w="med" len="med"/>
-                    </a:lnR>
-                    <a:lnT w="12700" cap="flat" cmpd="sng" algn="ctr">
-                      <a:solidFill>
-                        <a:srgbClr val="E3E8EC"/>
-                      </a:solidFill>
-                      <a:prstDash val="solid"/>
-                      <a:round/>
-                      <a:headEnd type="none" w="med" len="med"/>
-                      <a:tailEnd type="none" w="med" len="med"/>
-                    </a:lnT>
-                    <a:lnB w="12700" cap="flat" cmpd="sng" algn="ctr">
-                      <a:solidFill>
-                        <a:srgbClr val="E3E8EC"/>
-                      </a:solidFill>
-                      <a:prstDash val="solid"/>
-                      <a:round/>
-                      <a:headEnd type="none" w="med" len="med"/>
-                      <a:tailEnd type="none" w="med" len="med"/>
-                    </a:lnB>
-                    <a:solidFill>
-                      <a:srgbClr val="14202E"/>
-                    </a:solidFill>
-                  </a:tcPr>
-                </a:tc>
-              </a:tr>
-              <a:tr h="420624">
-                <a:tc>
-                  <a:txBody>
-                    <a:bodyPr/>
-                    <a:lstStyle/>
-                    <a:p>
-                      <a:pPr algn="l" indent="0" marL="0">
-                        <a:buNone/>
-                      </a:pPr>
-                      <a:r>
-                        <a:rPr lang="en-US" sz="1300" b="1" dirty="0">
-                          <a:solidFill>
-                            <a:srgbClr val="14202E"/>
-                          </a:solidFill>
-                          <a:latin typeface="Calibri" pitchFamily="34" charset="0"/>
-                          <a:ea typeface="Calibri" pitchFamily="34" charset="-122"/>
-                          <a:cs typeface="Calibri" pitchFamily="34" charset="-120"/>
-                        </a:rPr>
-                        <a:t>Acumuladores locales</a:t>
-                      </a:r>
-                      <a:endParaRPr lang="en-US" sz="1300" dirty="0">
-                        <a:latin typeface="Calibri" charset="0"/>
-                        <a:ea typeface="Calibri" charset="0"/>
-                        <a:cs typeface="Calibri" charset="0"/>
-                      </a:endParaRPr>
-                    </a:p>
-                  </a:txBody>
-                  <a:tcPr marL="91440" marR="91440" marT="45720" marB="45720" anchor="ctr">
-                    <a:lnL w="12700" cap="flat" cmpd="sng" algn="ctr">
-                      <a:solidFill>
-                        <a:srgbClr val="E3E8EC"/>
-                      </a:solidFill>
-                      <a:prstDash val="solid"/>
-                      <a:round/>
-                      <a:headEnd type="none" w="med" len="med"/>
-                      <a:tailEnd type="none" w="med" len="med"/>
-                    </a:lnL>
-                    <a:lnR w="12700" cap="flat" cmpd="sng" algn="ctr">
-                      <a:solidFill>
-                        <a:srgbClr val="E3E8EC"/>
-                      </a:solidFill>
-                      <a:prstDash val="solid"/>
-                      <a:round/>
-                      <a:headEnd type="none" w="med" len="med"/>
-                      <a:tailEnd type="none" w="med" len="med"/>
-                    </a:lnR>
-                    <a:lnT w="12700" cap="flat" cmpd="sng" algn="ctr">
-                      <a:solidFill>
-                        <a:srgbClr val="E3E8EC"/>
-                      </a:solidFill>
-                      <a:prstDash val="solid"/>
-                      <a:round/>
-                      <a:headEnd type="none" w="med" len="med"/>
-                      <a:tailEnd type="none" w="med" len="med"/>
-                    </a:lnT>
-                    <a:lnB w="12700" cap="flat" cmpd="sng" algn="ctr">
-                      <a:solidFill>
-                        <a:srgbClr val="E3E8EC"/>
-                      </a:solidFill>
-                      <a:prstDash val="solid"/>
-                      <a:round/>
-                      <a:headEnd type="none" w="med" len="med"/>
-                      <a:tailEnd type="none" w="med" len="med"/>
-                    </a:lnB>
-                    <a:solidFill>
-                      <a:srgbClr val="FFFFFF"/>
-                    </a:solidFill>
-                  </a:tcPr>
-                </a:tc>
-                <a:tc>
-                  <a:txBody>
-                    <a:bodyPr/>
-                    <a:lstStyle/>
-                    <a:p>
-                      <a:pPr algn="ctr" indent="0" marL="0">
-                        <a:buNone/>
-                      </a:pPr>
-                      <a:r>
-                        <a:rPr lang="en-US" sz="1300" dirty="0">
-                          <a:solidFill>
-                            <a:srgbClr val="14202E"/>
-                          </a:solidFill>
-                          <a:latin typeface="Calibri" pitchFamily="34" charset="0"/>
-                          <a:ea typeface="Calibri" pitchFamily="34" charset="-122"/>
-                          <a:cs typeface="Calibri" pitchFamily="34" charset="-120"/>
-                        </a:rPr>
-                        <a:t>6.84×</a:t>
-                      </a:r>
-                      <a:endParaRPr lang="en-US" sz="1300" dirty="0">
-                        <a:latin typeface="Calibri" charset="0"/>
-                        <a:ea typeface="Calibri" charset="0"/>
-                        <a:cs typeface="Calibri" charset="0"/>
-                      </a:endParaRPr>
-                    </a:p>
-                  </a:txBody>
-                  <a:tcPr marL="91440" marR="91440" marT="45720" marB="45720" anchor="ctr">
-                    <a:lnL w="12700" cap="flat" cmpd="sng" algn="ctr">
-                      <a:solidFill>
-                        <a:srgbClr val="E3E8EC"/>
-                      </a:solidFill>
-                      <a:prstDash val="solid"/>
-                      <a:round/>
-                      <a:headEnd type="none" w="med" len="med"/>
-                      <a:tailEnd type="none" w="med" len="med"/>
-                    </a:lnL>
-                    <a:lnR w="12700" cap="flat" cmpd="sng" algn="ctr">
-                      <a:solidFill>
-                        <a:srgbClr val="E3E8EC"/>
-                      </a:solidFill>
-                      <a:prstDash val="solid"/>
-                      <a:round/>
-                      <a:headEnd type="none" w="med" len="med"/>
-                      <a:tailEnd type="none" w="med" len="med"/>
-                    </a:lnR>
-                    <a:lnT w="12700" cap="flat" cmpd="sng" algn="ctr">
-                      <a:solidFill>
-                        <a:srgbClr val="E3E8EC"/>
-                      </a:solidFill>
-                      <a:prstDash val="solid"/>
-                      <a:round/>
-                      <a:headEnd type="none" w="med" len="med"/>
-                      <a:tailEnd type="none" w="med" len="med"/>
-                    </a:lnT>
-                    <a:lnB w="12700" cap="flat" cmpd="sng" algn="ctr">
-                      <a:solidFill>
-                        <a:srgbClr val="E3E8EC"/>
-                      </a:solidFill>
-                      <a:prstDash val="solid"/>
-                      <a:round/>
-                      <a:headEnd type="none" w="med" len="med"/>
-                      <a:tailEnd type="none" w="med" len="med"/>
-                    </a:lnB>
-                    <a:solidFill>
-                      <a:srgbClr val="FFFFFF"/>
-                    </a:solidFill>
-                  </a:tcPr>
-                </a:tc>
-                <a:tc>
-                  <a:txBody>
-                    <a:bodyPr/>
-                    <a:lstStyle/>
-                    <a:p>
-                      <a:pPr algn="ctr" indent="0" marL="0">
-                        <a:buNone/>
-                      </a:pPr>
-                      <a:r>
-                        <a:rPr lang="en-US" sz="1300" dirty="0">
-                          <a:solidFill>
-                            <a:srgbClr val="14202E"/>
-                          </a:solidFill>
-                          <a:latin typeface="Calibri" pitchFamily="34" charset="0"/>
-                          <a:ea typeface="Calibri" pitchFamily="34" charset="-122"/>
-                          <a:cs typeface="Calibri" pitchFamily="34" charset="-120"/>
-                        </a:rPr>
-                        <a:t>6.06×</a:t>
-                      </a:r>
-                      <a:endParaRPr lang="en-US" sz="1300" dirty="0">
-                        <a:latin typeface="Calibri" charset="0"/>
-                        <a:ea typeface="Calibri" charset="0"/>
-                        <a:cs typeface="Calibri" charset="0"/>
-                      </a:endParaRPr>
-                    </a:p>
-                  </a:txBody>
-                  <a:tcPr marL="91440" marR="91440" marT="45720" marB="45720" anchor="ctr">
-                    <a:lnL w="12700" cap="flat" cmpd="sng" algn="ctr">
-                      <a:solidFill>
-                        <a:srgbClr val="E3E8EC"/>
-                      </a:solidFill>
-                      <a:prstDash val="solid"/>
-                      <a:round/>
-                      <a:headEnd type="none" w="med" len="med"/>
-                      <a:tailEnd type="none" w="med" len="med"/>
-                    </a:lnL>
-                    <a:lnR w="12700" cap="flat" cmpd="sng" algn="ctr">
-                      <a:solidFill>
-                        <a:srgbClr val="E3E8EC"/>
-                      </a:solidFill>
-                      <a:prstDash val="solid"/>
-                      <a:round/>
-                      <a:headEnd type="none" w="med" len="med"/>
-                      <a:tailEnd type="none" w="med" len="med"/>
-                    </a:lnR>
-                    <a:lnT w="12700" cap="flat" cmpd="sng" algn="ctr">
-                      <a:solidFill>
-                        <a:srgbClr val="E3E8EC"/>
-                      </a:solidFill>
-                      <a:prstDash val="solid"/>
-                      <a:round/>
-                      <a:headEnd type="none" w="med" len="med"/>
-                      <a:tailEnd type="none" w="med" len="med"/>
-                    </a:lnT>
-                    <a:lnB w="12700" cap="flat" cmpd="sng" algn="ctr">
-                      <a:solidFill>
-                        <a:srgbClr val="E3E8EC"/>
-                      </a:solidFill>
-                      <a:prstDash val="solid"/>
-                      <a:round/>
-                      <a:headEnd type="none" w="med" len="med"/>
-                      <a:tailEnd type="none" w="med" len="med"/>
-                    </a:lnB>
-                    <a:solidFill>
-                      <a:srgbClr val="FFFFFF"/>
-                    </a:solidFill>
-                  </a:tcPr>
-                </a:tc>
-                <a:tc>
-                  <a:txBody>
-                    <a:bodyPr/>
-                    <a:lstStyle/>
-                    <a:p>
-                      <a:pPr algn="ctr" indent="0" marL="0">
-                        <a:buNone/>
-                      </a:pPr>
-                      <a:r>
-                        <a:rPr lang="en-US" sz="1300" dirty="0">
-                          <a:solidFill>
-                            <a:srgbClr val="14202E"/>
-                          </a:solidFill>
-                          <a:latin typeface="Calibri" pitchFamily="34" charset="0"/>
-                          <a:ea typeface="Calibri" pitchFamily="34" charset="-122"/>
-                          <a:cs typeface="Calibri" pitchFamily="34" charset="-120"/>
-                        </a:rPr>
-                        <a:t>6.00×</a:t>
-                      </a:r>
-                      <a:endParaRPr lang="en-US" sz="1300" dirty="0">
-                        <a:latin typeface="Calibri" charset="0"/>
-                        <a:ea typeface="Calibri" charset="0"/>
-                        <a:cs typeface="Calibri" charset="0"/>
-                      </a:endParaRPr>
-                    </a:p>
-                  </a:txBody>
-                  <a:tcPr marL="91440" marR="91440" marT="45720" marB="45720" anchor="ctr">
-                    <a:lnL w="12700" cap="flat" cmpd="sng" algn="ctr">
-                      <a:solidFill>
-                        <a:srgbClr val="E3E8EC"/>
-                      </a:solidFill>
-                      <a:prstDash val="solid"/>
-                      <a:round/>
-                      <a:headEnd type="none" w="med" len="med"/>
-                      <a:tailEnd type="none" w="med" len="med"/>
-                    </a:lnL>
-                    <a:lnR w="12700" cap="flat" cmpd="sng" algn="ctr">
-                      <a:solidFill>
-                        <a:srgbClr val="E3E8EC"/>
-                      </a:solidFill>
-                      <a:prstDash val="solid"/>
-                      <a:round/>
-                      <a:headEnd type="none" w="med" len="med"/>
-                      <a:tailEnd type="none" w="med" len="med"/>
-                    </a:lnR>
-                    <a:lnT w="12700" cap="flat" cmpd="sng" algn="ctr">
-                      <a:solidFill>
-                        <a:srgbClr val="E3E8EC"/>
-                      </a:solidFill>
-                      <a:prstDash val="solid"/>
-                      <a:round/>
-                      <a:headEnd type="none" w="med" len="med"/>
-                      <a:tailEnd type="none" w="med" len="med"/>
-                    </a:lnT>
-                    <a:lnB w="12700" cap="flat" cmpd="sng" algn="ctr">
-                      <a:solidFill>
-                        <a:srgbClr val="E3E8EC"/>
-                      </a:solidFill>
-                      <a:prstDash val="solid"/>
-                      <a:round/>
-                      <a:headEnd type="none" w="med" len="med"/>
-                      <a:tailEnd type="none" w="med" len="med"/>
-                    </a:lnB>
-                    <a:solidFill>
-                      <a:srgbClr val="FFFFFF"/>
-                    </a:solidFill>
-                  </a:tcPr>
-                </a:tc>
-                <a:tc>
-                  <a:txBody>
-                    <a:bodyPr/>
-                    <a:lstStyle/>
-                    <a:p>
-                      <a:pPr algn="ctr" indent="0" marL="0">
-                        <a:buNone/>
-                      </a:pPr>
-                      <a:r>
-                        <a:rPr lang="en-US" sz="1300" b="1" dirty="0">
-                          <a:solidFill>
-                            <a:srgbClr val="00A896"/>
-                          </a:solidFill>
-                          <a:latin typeface="Calibri" pitchFamily="34" charset="0"/>
-                          <a:ea typeface="Calibri" pitchFamily="34" charset="-122"/>
-                          <a:cs typeface="Calibri" pitchFamily="34" charset="-120"/>
-                        </a:rPr>
-                        <a:t>6.30×</a:t>
-                      </a:r>
-                      <a:endParaRPr lang="en-US" sz="1300" dirty="0">
-                        <a:latin typeface="Calibri" charset="0"/>
-                        <a:ea typeface="Calibri" charset="0"/>
-                        <a:cs typeface="Calibri" charset="0"/>
-                      </a:endParaRPr>
-                    </a:p>
-                  </a:txBody>
-                  <a:tcPr marL="91440" marR="91440" marT="45720" marB="45720" anchor="ctr">
-                    <a:lnL w="12700" cap="flat" cmpd="sng" algn="ctr">
-                      <a:solidFill>
-                        <a:srgbClr val="E3E8EC"/>
-                      </a:solidFill>
-                      <a:prstDash val="solid"/>
-                      <a:round/>
-                      <a:headEnd type="none" w="med" len="med"/>
-                      <a:tailEnd type="none" w="med" len="med"/>
-                    </a:lnL>
-                    <a:lnR w="12700" cap="flat" cmpd="sng" algn="ctr">
-                      <a:solidFill>
-                        <a:srgbClr val="E3E8EC"/>
-                      </a:solidFill>
-                      <a:prstDash val="solid"/>
-                      <a:round/>
-                      <a:headEnd type="none" w="med" len="med"/>
-                      <a:tailEnd type="none" w="med" len="med"/>
-                    </a:lnR>
-                    <a:lnT w="12700" cap="flat" cmpd="sng" algn="ctr">
-                      <a:solidFill>
-                        <a:srgbClr val="E3E8EC"/>
-                      </a:solidFill>
-                      <a:prstDash val="solid"/>
-                      <a:round/>
-                      <a:headEnd type="none" w="med" len="med"/>
-                      <a:tailEnd type="none" w="med" len="med"/>
-                    </a:lnT>
-                    <a:lnB w="12700" cap="flat" cmpd="sng" algn="ctr">
-                      <a:solidFill>
-                        <a:srgbClr val="E3E8EC"/>
-                      </a:solidFill>
-                      <a:prstDash val="solid"/>
-                      <a:round/>
-                      <a:headEnd type="none" w="med" len="med"/>
-                      <a:tailEnd type="none" w="med" len="med"/>
-                    </a:lnB>
-                    <a:solidFill>
-                      <a:srgbClr val="FFFFFF"/>
-                    </a:solidFill>
-                  </a:tcPr>
-                </a:tc>
-              </a:tr>
-              <a:tr h="420624">
-                <a:tc>
-                  <a:txBody>
-                    <a:bodyPr/>
-                    <a:lstStyle/>
-                    <a:p>
-                      <a:pPr algn="l" indent="0" marL="0">
-                        <a:buNone/>
-                      </a:pPr>
-                      <a:r>
-                        <a:rPr lang="en-US" sz="1300" b="1" dirty="0">
-                          <a:solidFill>
-                            <a:srgbClr val="14202E"/>
-                          </a:solidFill>
-                          <a:latin typeface="Calibri" pitchFamily="34" charset="0"/>
-                          <a:ea typeface="Calibri" pitchFamily="34" charset="-122"/>
-                          <a:cs typeface="Calibri" pitchFamily="34" charset="-120"/>
-                        </a:rPr>
-                        <a:t>Reducción en árbol</a:t>
-                      </a:r>
-                      <a:endParaRPr lang="en-US" sz="1300" dirty="0">
-                        <a:latin typeface="Calibri" charset="0"/>
-                        <a:ea typeface="Calibri" charset="0"/>
-                        <a:cs typeface="Calibri" charset="0"/>
-                      </a:endParaRPr>
-                    </a:p>
-                  </a:txBody>
-                  <a:tcPr marL="91440" marR="91440" marT="45720" marB="45720" anchor="ctr">
-                    <a:lnL w="12700" cap="flat" cmpd="sng" algn="ctr">
-                      <a:solidFill>
-                        <a:srgbClr val="E3E8EC"/>
-                      </a:solidFill>
-                      <a:prstDash val="solid"/>
-                      <a:round/>
-                      <a:headEnd type="none" w="med" len="med"/>
-                      <a:tailEnd type="none" w="med" len="med"/>
-                    </a:lnL>
-                    <a:lnR w="12700" cap="flat" cmpd="sng" algn="ctr">
-                      <a:solidFill>
-                        <a:srgbClr val="E3E8EC"/>
-                      </a:solidFill>
-                      <a:prstDash val="solid"/>
-                      <a:round/>
-                      <a:headEnd type="none" w="med" len="med"/>
-                      <a:tailEnd type="none" w="med" len="med"/>
-                    </a:lnR>
-                    <a:lnT w="12700" cap="flat" cmpd="sng" algn="ctr">
-                      <a:solidFill>
-                        <a:srgbClr val="E3E8EC"/>
-                      </a:solidFill>
-                      <a:prstDash val="solid"/>
-                      <a:round/>
-                      <a:headEnd type="none" w="med" len="med"/>
-                      <a:tailEnd type="none" w="med" len="med"/>
-                    </a:lnT>
-                    <a:lnB w="12700" cap="flat" cmpd="sng" algn="ctr">
-                      <a:solidFill>
-                        <a:srgbClr val="E3E8EC"/>
-                      </a:solidFill>
-                      <a:prstDash val="solid"/>
-                      <a:round/>
-                      <a:headEnd type="none" w="med" len="med"/>
-                      <a:tailEnd type="none" w="med" len="med"/>
-                    </a:lnB>
-                    <a:solidFill>
-                      <a:srgbClr val="EDF1F4"/>
-                    </a:solidFill>
-                  </a:tcPr>
-                </a:tc>
-                <a:tc>
-                  <a:txBody>
-                    <a:bodyPr/>
-                    <a:lstStyle/>
-                    <a:p>
-                      <a:pPr algn="ctr" indent="0" marL="0">
-                        <a:buNone/>
-                      </a:pPr>
-                      <a:r>
-                        <a:rPr lang="en-US" sz="1300" dirty="0">
-                          <a:solidFill>
-                            <a:srgbClr val="14202E"/>
-                          </a:solidFill>
-                          <a:latin typeface="Calibri" pitchFamily="34" charset="0"/>
-                          <a:ea typeface="Calibri" pitchFamily="34" charset="-122"/>
-                          <a:cs typeface="Calibri" pitchFamily="34" charset="-120"/>
-                        </a:rPr>
-                        <a:t>6.61×</a:t>
-                      </a:r>
-                      <a:endParaRPr lang="en-US" sz="1300" dirty="0">
-                        <a:latin typeface="Calibri" charset="0"/>
-                        <a:ea typeface="Calibri" charset="0"/>
-                        <a:cs typeface="Calibri" charset="0"/>
-                      </a:endParaRPr>
-                    </a:p>
-                  </a:txBody>
-                  <a:tcPr marL="91440" marR="91440" marT="45720" marB="45720" anchor="ctr">
-                    <a:lnL w="12700" cap="flat" cmpd="sng" algn="ctr">
-                      <a:solidFill>
-                        <a:srgbClr val="E3E8EC"/>
-                      </a:solidFill>
-                      <a:prstDash val="solid"/>
-                      <a:round/>
-                      <a:headEnd type="none" w="med" len="med"/>
-                      <a:tailEnd type="none" w="med" len="med"/>
-                    </a:lnL>
-                    <a:lnR w="12700" cap="flat" cmpd="sng" algn="ctr">
-                      <a:solidFill>
-                        <a:srgbClr val="E3E8EC"/>
-                      </a:solidFill>
-                      <a:prstDash val="solid"/>
-                      <a:round/>
-                      <a:headEnd type="none" w="med" len="med"/>
-                      <a:tailEnd type="none" w="med" len="med"/>
-                    </a:lnR>
-                    <a:lnT w="12700" cap="flat" cmpd="sng" algn="ctr">
-                      <a:solidFill>
-                        <a:srgbClr val="E3E8EC"/>
-                      </a:solidFill>
-                      <a:prstDash val="solid"/>
-                      <a:round/>
-                      <a:headEnd type="none" w="med" len="med"/>
-                      <a:tailEnd type="none" w="med" len="med"/>
-                    </a:lnT>
-                    <a:lnB w="12700" cap="flat" cmpd="sng" algn="ctr">
-                      <a:solidFill>
-                        <a:srgbClr val="E3E8EC"/>
-                      </a:solidFill>
-                      <a:prstDash val="solid"/>
-                      <a:round/>
-                      <a:headEnd type="none" w="med" len="med"/>
-                      <a:tailEnd type="none" w="med" len="med"/>
-                    </a:lnB>
-                    <a:solidFill>
-                      <a:srgbClr val="EDF1F4"/>
-                    </a:solidFill>
-                  </a:tcPr>
-                </a:tc>
-                <a:tc>
-                  <a:txBody>
-                    <a:bodyPr/>
-                    <a:lstStyle/>
-                    <a:p>
-                      <a:pPr algn="ctr" indent="0" marL="0">
-                        <a:buNone/>
-                      </a:pPr>
-                      <a:r>
-                        <a:rPr lang="en-US" sz="1300" dirty="0">
-                          <a:solidFill>
-                            <a:srgbClr val="14202E"/>
-                          </a:solidFill>
-                          <a:latin typeface="Calibri" pitchFamily="34" charset="0"/>
-                          <a:ea typeface="Calibri" pitchFamily="34" charset="-122"/>
-                          <a:cs typeface="Calibri" pitchFamily="34" charset="-120"/>
-                        </a:rPr>
-                        <a:t>6.19×</a:t>
-                      </a:r>
-                      <a:endParaRPr lang="en-US" sz="1300" dirty="0">
-                        <a:latin typeface="Calibri" charset="0"/>
-                        <a:ea typeface="Calibri" charset="0"/>
-                        <a:cs typeface="Calibri" charset="0"/>
-                      </a:endParaRPr>
-                    </a:p>
-                  </a:txBody>
-                  <a:tcPr marL="91440" marR="91440" marT="45720" marB="45720" anchor="ctr">
-                    <a:lnL w="12700" cap="flat" cmpd="sng" algn="ctr">
-                      <a:solidFill>
-                        <a:srgbClr val="E3E8EC"/>
-                      </a:solidFill>
-                      <a:prstDash val="solid"/>
-                      <a:round/>
-                      <a:headEnd type="none" w="med" len="med"/>
-                      <a:tailEnd type="none" w="med" len="med"/>
-                    </a:lnL>
-                    <a:lnR w="12700" cap="flat" cmpd="sng" algn="ctr">
-                      <a:solidFill>
-                        <a:srgbClr val="E3E8EC"/>
-                      </a:solidFill>
-                      <a:prstDash val="solid"/>
-                      <a:round/>
-                      <a:headEnd type="none" w="med" len="med"/>
-                      <a:tailEnd type="none" w="med" len="med"/>
-                    </a:lnR>
-                    <a:lnT w="12700" cap="flat" cmpd="sng" algn="ctr">
-                      <a:solidFill>
-                        <a:srgbClr val="E3E8EC"/>
-                      </a:solidFill>
-                      <a:prstDash val="solid"/>
-                      <a:round/>
-                      <a:headEnd type="none" w="med" len="med"/>
-                      <a:tailEnd type="none" w="med" len="med"/>
-                    </a:lnT>
-                    <a:lnB w="12700" cap="flat" cmpd="sng" algn="ctr">
-                      <a:solidFill>
-                        <a:srgbClr val="E3E8EC"/>
-                      </a:solidFill>
-                      <a:prstDash val="solid"/>
-                      <a:round/>
-                      <a:headEnd type="none" w="med" len="med"/>
-                      <a:tailEnd type="none" w="med" len="med"/>
-                    </a:lnB>
-                    <a:solidFill>
-                      <a:srgbClr val="EDF1F4"/>
-                    </a:solidFill>
-                  </a:tcPr>
-                </a:tc>
-                <a:tc>
-                  <a:txBody>
-                    <a:bodyPr/>
-                    <a:lstStyle/>
-                    <a:p>
-                      <a:pPr algn="ctr" indent="0" marL="0">
-                        <a:buNone/>
-                      </a:pPr>
-                      <a:r>
-                        <a:rPr lang="en-US" sz="1300" dirty="0">
-                          <a:solidFill>
-                            <a:srgbClr val="14202E"/>
-                          </a:solidFill>
-                          <a:latin typeface="Calibri" pitchFamily="34" charset="0"/>
-                          <a:ea typeface="Calibri" pitchFamily="34" charset="-122"/>
-                          <a:cs typeface="Calibri" pitchFamily="34" charset="-120"/>
-                        </a:rPr>
-                        <a:t>5.64×</a:t>
-                      </a:r>
-                      <a:endParaRPr lang="en-US" sz="1300" dirty="0">
-                        <a:latin typeface="Calibri" charset="0"/>
-                        <a:ea typeface="Calibri" charset="0"/>
-                        <a:cs typeface="Calibri" charset="0"/>
-                      </a:endParaRPr>
-                    </a:p>
-                  </a:txBody>
-                  <a:tcPr marL="91440" marR="91440" marT="45720" marB="45720" anchor="ctr">
-                    <a:lnL w="12700" cap="flat" cmpd="sng" algn="ctr">
-                      <a:solidFill>
-                        <a:srgbClr val="E3E8EC"/>
-                      </a:solidFill>
-                      <a:prstDash val="solid"/>
-                      <a:round/>
-                      <a:headEnd type="none" w="med" len="med"/>
-                      <a:tailEnd type="none" w="med" len="med"/>
-                    </a:lnL>
-                    <a:lnR w="12700" cap="flat" cmpd="sng" algn="ctr">
-                      <a:solidFill>
-                        <a:srgbClr val="E3E8EC"/>
-                      </a:solidFill>
-                      <a:prstDash val="solid"/>
-                      <a:round/>
-                      <a:headEnd type="none" w="med" len="med"/>
-                      <a:tailEnd type="none" w="med" len="med"/>
-                    </a:lnR>
-                    <a:lnT w="12700" cap="flat" cmpd="sng" algn="ctr">
-                      <a:solidFill>
-                        <a:srgbClr val="E3E8EC"/>
-                      </a:solidFill>
-                      <a:prstDash val="solid"/>
-                      <a:round/>
-                      <a:headEnd type="none" w="med" len="med"/>
-                      <a:tailEnd type="none" w="med" len="med"/>
-                    </a:lnT>
-                    <a:lnB w="12700" cap="flat" cmpd="sng" algn="ctr">
-                      <a:solidFill>
-                        <a:srgbClr val="E3E8EC"/>
-                      </a:solidFill>
-                      <a:prstDash val="solid"/>
-                      <a:round/>
-                      <a:headEnd type="none" w="med" len="med"/>
-                      <a:tailEnd type="none" w="med" len="med"/>
-                    </a:lnB>
-                    <a:solidFill>
-                      <a:srgbClr val="EDF1F4"/>
-                    </a:solidFill>
-                  </a:tcPr>
-                </a:tc>
-                <a:tc>
-                  <a:txBody>
-                    <a:bodyPr/>
-                    <a:lstStyle/>
-                    <a:p>
-                      <a:pPr algn="ctr" indent="0" marL="0">
-                        <a:buNone/>
-                      </a:pPr>
-                      <a:r>
-                        <a:rPr lang="en-US" sz="1300" b="1" dirty="0">
-                          <a:solidFill>
-                            <a:srgbClr val="00A896"/>
-                          </a:solidFill>
-                          <a:latin typeface="Calibri" pitchFamily="34" charset="0"/>
-                          <a:ea typeface="Calibri" pitchFamily="34" charset="-122"/>
-                          <a:cs typeface="Calibri" pitchFamily="34" charset="-120"/>
-                        </a:rPr>
-                        <a:t>6.15×</a:t>
-                      </a:r>
-                      <a:endParaRPr lang="en-US" sz="1300" dirty="0">
-                        <a:latin typeface="Calibri" charset="0"/>
-                        <a:ea typeface="Calibri" charset="0"/>
-                        <a:cs typeface="Calibri" charset="0"/>
-                      </a:endParaRPr>
-                    </a:p>
-                  </a:txBody>
-                  <a:tcPr marL="91440" marR="91440" marT="45720" marB="45720" anchor="ctr">
-                    <a:lnL w="12700" cap="flat" cmpd="sng" algn="ctr">
-                      <a:solidFill>
-                        <a:srgbClr val="E3E8EC"/>
-                      </a:solidFill>
-                      <a:prstDash val="solid"/>
-                      <a:round/>
-                      <a:headEnd type="none" w="med" len="med"/>
-                      <a:tailEnd type="none" w="med" len="med"/>
-                    </a:lnL>
-                    <a:lnR w="12700" cap="flat" cmpd="sng" algn="ctr">
-                      <a:solidFill>
-                        <a:srgbClr val="E3E8EC"/>
-                      </a:solidFill>
-                      <a:prstDash val="solid"/>
-                      <a:round/>
-                      <a:headEnd type="none" w="med" len="med"/>
-                      <a:tailEnd type="none" w="med" len="med"/>
-                    </a:lnR>
-                    <a:lnT w="12700" cap="flat" cmpd="sng" algn="ctr">
-                      <a:solidFill>
-                        <a:srgbClr val="E3E8EC"/>
-                      </a:solidFill>
-                      <a:prstDash val="solid"/>
-                      <a:round/>
-                      <a:headEnd type="none" w="med" len="med"/>
-                      <a:tailEnd type="none" w="med" len="med"/>
-                    </a:lnT>
-                    <a:lnB w="12700" cap="flat" cmpd="sng" algn="ctr">
-                      <a:solidFill>
-                        <a:srgbClr val="E3E8EC"/>
-                      </a:solidFill>
-                      <a:prstDash val="solid"/>
-                      <a:round/>
-                      <a:headEnd type="none" w="med" len="med"/>
-                      <a:tailEnd type="none" w="med" len="med"/>
-                    </a:lnB>
-                    <a:solidFill>
-                      <a:srgbClr val="EDF1F4"/>
-                    </a:solidFill>
-                  </a:tcPr>
-                </a:tc>
-              </a:tr>
-              <a:tr h="420624">
-                <a:tc>
-                  <a:txBody>
-                    <a:bodyPr/>
-                    <a:lstStyle/>
-                    <a:p>
-                      <a:pPr algn="l" indent="0" marL="0">
-                        <a:buNone/>
-                      </a:pPr>
-                      <a:r>
-                        <a:rPr lang="en-US" sz="1300" b="1" dirty="0">
-                          <a:solidFill>
-                            <a:srgbClr val="14202E"/>
-                          </a:solidFill>
-                          <a:latin typeface="Calibri" pitchFamily="34" charset="0"/>
-                          <a:ea typeface="Calibri" pitchFamily="34" charset="-122"/>
-                          <a:cs typeface="Calibri" pitchFamily="34" charset="-120"/>
-                        </a:rPr>
-                        <a:t>Grano grueso</a:t>
-                      </a:r>
-                      <a:endParaRPr lang="en-US" sz="1300" dirty="0">
-                        <a:latin typeface="Calibri" charset="0"/>
-                        <a:ea typeface="Calibri" charset="0"/>
-                        <a:cs typeface="Calibri" charset="0"/>
-                      </a:endParaRPr>
-                    </a:p>
-                  </a:txBody>
-                  <a:tcPr marL="91440" marR="91440" marT="45720" marB="45720" anchor="ctr">
-                    <a:lnL w="12700" cap="flat" cmpd="sng" algn="ctr">
-                      <a:solidFill>
-                        <a:srgbClr val="E3E8EC"/>
-                      </a:solidFill>
-                      <a:prstDash val="solid"/>
-                      <a:round/>
-                      <a:headEnd type="none" w="med" len="med"/>
-                      <a:tailEnd type="none" w="med" len="med"/>
-                    </a:lnL>
-                    <a:lnR w="12700" cap="flat" cmpd="sng" algn="ctr">
-                      <a:solidFill>
-                        <a:srgbClr val="E3E8EC"/>
-                      </a:solidFill>
-                      <a:prstDash val="solid"/>
-                      <a:round/>
-                      <a:headEnd type="none" w="med" len="med"/>
-                      <a:tailEnd type="none" w="med" len="med"/>
-                    </a:lnR>
-                    <a:lnT w="12700" cap="flat" cmpd="sng" algn="ctr">
-                      <a:solidFill>
-                        <a:srgbClr val="E3E8EC"/>
-                      </a:solidFill>
-                      <a:prstDash val="solid"/>
-                      <a:round/>
-                      <a:headEnd type="none" w="med" len="med"/>
-                      <a:tailEnd type="none" w="med" len="med"/>
-                    </a:lnT>
-                    <a:lnB w="12700" cap="flat" cmpd="sng" algn="ctr">
-                      <a:solidFill>
-                        <a:srgbClr val="E3E8EC"/>
-                      </a:solidFill>
-                      <a:prstDash val="solid"/>
-                      <a:round/>
-                      <a:headEnd type="none" w="med" len="med"/>
-                      <a:tailEnd type="none" w="med" len="med"/>
-                    </a:lnB>
-                    <a:solidFill>
-                      <a:srgbClr val="FFFFFF"/>
-                    </a:solidFill>
-                  </a:tcPr>
-                </a:tc>
-                <a:tc>
-                  <a:txBody>
-                    <a:bodyPr/>
-                    <a:lstStyle/>
-                    <a:p>
-                      <a:pPr algn="ctr" indent="0" marL="0">
-                        <a:buNone/>
-                      </a:pPr>
-                      <a:r>
-                        <a:rPr lang="en-US" sz="1300" dirty="0">
-                          <a:solidFill>
-                            <a:srgbClr val="14202E"/>
-                          </a:solidFill>
-                          <a:latin typeface="Calibri" pitchFamily="34" charset="0"/>
-                          <a:ea typeface="Calibri" pitchFamily="34" charset="-122"/>
-                          <a:cs typeface="Calibri" pitchFamily="34" charset="-120"/>
-                        </a:rPr>
-                        <a:t>6.28×</a:t>
-                      </a:r>
-                      <a:endParaRPr lang="en-US" sz="1300" dirty="0">
-                        <a:latin typeface="Calibri" charset="0"/>
-                        <a:ea typeface="Calibri" charset="0"/>
-                        <a:cs typeface="Calibri" charset="0"/>
-                      </a:endParaRPr>
-                    </a:p>
-                  </a:txBody>
-                  <a:tcPr marL="91440" marR="91440" marT="45720" marB="45720" anchor="ctr">
-                    <a:lnL w="12700" cap="flat" cmpd="sng" algn="ctr">
-                      <a:solidFill>
-                        <a:srgbClr val="E3E8EC"/>
-                      </a:solidFill>
-                      <a:prstDash val="solid"/>
-                      <a:round/>
-                      <a:headEnd type="none" w="med" len="med"/>
-                      <a:tailEnd type="none" w="med" len="med"/>
-                    </a:lnL>
-                    <a:lnR w="12700" cap="flat" cmpd="sng" algn="ctr">
-                      <a:solidFill>
-                        <a:srgbClr val="E3E8EC"/>
-                      </a:solidFill>
-                      <a:prstDash val="solid"/>
-                      <a:round/>
-                      <a:headEnd type="none" w="med" len="med"/>
-                      <a:tailEnd type="none" w="med" len="med"/>
-                    </a:lnR>
-                    <a:lnT w="12700" cap="flat" cmpd="sng" algn="ctr">
-                      <a:solidFill>
-                        <a:srgbClr val="E3E8EC"/>
-                      </a:solidFill>
-                      <a:prstDash val="solid"/>
-                      <a:round/>
-                      <a:headEnd type="none" w="med" len="med"/>
-                      <a:tailEnd type="none" w="med" len="med"/>
-                    </a:lnT>
-                    <a:lnB w="12700" cap="flat" cmpd="sng" algn="ctr">
-                      <a:solidFill>
-                        <a:srgbClr val="E3E8EC"/>
-                      </a:solidFill>
-                      <a:prstDash val="solid"/>
-                      <a:round/>
-                      <a:headEnd type="none" w="med" len="med"/>
-                      <a:tailEnd type="none" w="med" len="med"/>
-                    </a:lnB>
-                    <a:solidFill>
-                      <a:srgbClr val="FFFFFF"/>
-                    </a:solidFill>
-                  </a:tcPr>
-                </a:tc>
-                <a:tc>
-                  <a:txBody>
-                    <a:bodyPr/>
-                    <a:lstStyle/>
-                    <a:p>
-                      <a:pPr algn="ctr" indent="0" marL="0">
-                        <a:buNone/>
-                      </a:pPr>
-                      <a:r>
-                        <a:rPr lang="en-US" sz="1300" dirty="0">
-                          <a:solidFill>
-                            <a:srgbClr val="14202E"/>
-                          </a:solidFill>
-                          <a:latin typeface="Calibri" pitchFamily="34" charset="0"/>
-                          <a:ea typeface="Calibri" pitchFamily="34" charset="-122"/>
-                          <a:cs typeface="Calibri" pitchFamily="34" charset="-120"/>
-                        </a:rPr>
-                        <a:t>5.95×</a:t>
-                      </a:r>
-                      <a:endParaRPr lang="en-US" sz="1300" dirty="0">
-                        <a:latin typeface="Calibri" charset="0"/>
-                        <a:ea typeface="Calibri" charset="0"/>
-                        <a:cs typeface="Calibri" charset="0"/>
-                      </a:endParaRPr>
-                    </a:p>
-                  </a:txBody>
-                  <a:tcPr marL="91440" marR="91440" marT="45720" marB="45720" anchor="ctr">
-                    <a:lnL w="12700" cap="flat" cmpd="sng" algn="ctr">
-                      <a:solidFill>
-                        <a:srgbClr val="E3E8EC"/>
-                      </a:solidFill>
-                      <a:prstDash val="solid"/>
-                      <a:round/>
-                      <a:headEnd type="none" w="med" len="med"/>
-                      <a:tailEnd type="none" w="med" len="med"/>
-                    </a:lnL>
-                    <a:lnR w="12700" cap="flat" cmpd="sng" algn="ctr">
-                      <a:solidFill>
-                        <a:srgbClr val="E3E8EC"/>
-                      </a:solidFill>
-                      <a:prstDash val="solid"/>
-                      <a:round/>
-                      <a:headEnd type="none" w="med" len="med"/>
-                      <a:tailEnd type="none" w="med" len="med"/>
-                    </a:lnR>
-                    <a:lnT w="12700" cap="flat" cmpd="sng" algn="ctr">
-                      <a:solidFill>
-                        <a:srgbClr val="E3E8EC"/>
-                      </a:solidFill>
-                      <a:prstDash val="solid"/>
-                      <a:round/>
-                      <a:headEnd type="none" w="med" len="med"/>
-                      <a:tailEnd type="none" w="med" len="med"/>
-                    </a:lnT>
-                    <a:lnB w="12700" cap="flat" cmpd="sng" algn="ctr">
-                      <a:solidFill>
-                        <a:srgbClr val="E3E8EC"/>
-                      </a:solidFill>
-                      <a:prstDash val="solid"/>
-                      <a:round/>
-                      <a:headEnd type="none" w="med" len="med"/>
-                      <a:tailEnd type="none" w="med" len="med"/>
-                    </a:lnB>
-                    <a:solidFill>
-                      <a:srgbClr val="FFFFFF"/>
-                    </a:solidFill>
-                  </a:tcPr>
-                </a:tc>
-                <a:tc>
-                  <a:txBody>
-                    <a:bodyPr/>
-                    <a:lstStyle/>
-                    <a:p>
-                      <a:pPr algn="ctr" indent="0" marL="0">
-                        <a:buNone/>
-                      </a:pPr>
-                      <a:r>
-                        <a:rPr lang="en-US" sz="1300" dirty="0">
-                          <a:solidFill>
-                            <a:srgbClr val="14202E"/>
-                          </a:solidFill>
-                          <a:latin typeface="Calibri" pitchFamily="34" charset="0"/>
-                          <a:ea typeface="Calibri" pitchFamily="34" charset="-122"/>
-                          <a:cs typeface="Calibri" pitchFamily="34" charset="-120"/>
-                        </a:rPr>
-                        <a:t>5.94×</a:t>
-                      </a:r>
-                      <a:endParaRPr lang="en-US" sz="1300" dirty="0">
-                        <a:latin typeface="Calibri" charset="0"/>
-                        <a:ea typeface="Calibri" charset="0"/>
-                        <a:cs typeface="Calibri" charset="0"/>
-                      </a:endParaRPr>
-                    </a:p>
-                  </a:txBody>
-                  <a:tcPr marL="91440" marR="91440" marT="45720" marB="45720" anchor="ctr">
-                    <a:lnL w="12700" cap="flat" cmpd="sng" algn="ctr">
-                      <a:solidFill>
-                        <a:srgbClr val="E3E8EC"/>
-                      </a:solidFill>
-                      <a:prstDash val="solid"/>
-                      <a:round/>
-                      <a:headEnd type="none" w="med" len="med"/>
-                      <a:tailEnd type="none" w="med" len="med"/>
-                    </a:lnL>
-                    <a:lnR w="12700" cap="flat" cmpd="sng" algn="ctr">
-                      <a:solidFill>
-                        <a:srgbClr val="E3E8EC"/>
-                      </a:solidFill>
-                      <a:prstDash val="solid"/>
-                      <a:round/>
-                      <a:headEnd type="none" w="med" len="med"/>
-                      <a:tailEnd type="none" w="med" len="med"/>
-                    </a:lnR>
-                    <a:lnT w="12700" cap="flat" cmpd="sng" algn="ctr">
-                      <a:solidFill>
-                        <a:srgbClr val="E3E8EC"/>
-                      </a:solidFill>
-                      <a:prstDash val="solid"/>
-                      <a:round/>
-                      <a:headEnd type="none" w="med" len="med"/>
-                      <a:tailEnd type="none" w="med" len="med"/>
-                    </a:lnT>
-                    <a:lnB w="12700" cap="flat" cmpd="sng" algn="ctr">
-                      <a:solidFill>
-                        <a:srgbClr val="E3E8EC"/>
-                      </a:solidFill>
-                      <a:prstDash val="solid"/>
-                      <a:round/>
-                      <a:headEnd type="none" w="med" len="med"/>
-                      <a:tailEnd type="none" w="med" len="med"/>
-                    </a:lnB>
-                    <a:solidFill>
-                      <a:srgbClr val="FFFFFF"/>
-                    </a:solidFill>
-                  </a:tcPr>
-                </a:tc>
-                <a:tc>
-                  <a:txBody>
-                    <a:bodyPr/>
-                    <a:lstStyle/>
-                    <a:p>
-                      <a:pPr algn="ctr" indent="0" marL="0">
-                        <a:buNone/>
-                      </a:pPr>
-                      <a:r>
-                        <a:rPr lang="en-US" sz="1300" b="1" dirty="0">
-                          <a:solidFill>
-                            <a:srgbClr val="00A896"/>
-                          </a:solidFill>
-                          <a:latin typeface="Calibri" pitchFamily="34" charset="0"/>
-                          <a:ea typeface="Calibri" pitchFamily="34" charset="-122"/>
-                          <a:cs typeface="Calibri" pitchFamily="34" charset="-120"/>
-                        </a:rPr>
-                        <a:t>6.06×</a:t>
-                      </a:r>
-                      <a:endParaRPr lang="en-US" sz="1300" dirty="0">
-                        <a:latin typeface="Calibri" charset="0"/>
-                        <a:ea typeface="Calibri" charset="0"/>
-                        <a:cs typeface="Calibri" charset="0"/>
-                      </a:endParaRPr>
-                    </a:p>
-                  </a:txBody>
-                  <a:tcPr marL="91440" marR="91440" marT="45720" marB="45720" anchor="ctr">
-                    <a:lnL w="12700" cap="flat" cmpd="sng" algn="ctr">
-                      <a:solidFill>
-                        <a:srgbClr val="E3E8EC"/>
-                      </a:solidFill>
-                      <a:prstDash val="solid"/>
-                      <a:round/>
-                      <a:headEnd type="none" w="med" len="med"/>
-                      <a:tailEnd type="none" w="med" len="med"/>
-                    </a:lnL>
-                    <a:lnR w="12700" cap="flat" cmpd="sng" algn="ctr">
-                      <a:solidFill>
-                        <a:srgbClr val="E3E8EC"/>
-                      </a:solidFill>
-                      <a:prstDash val="solid"/>
-                      <a:round/>
-                      <a:headEnd type="none" w="med" len="med"/>
-                      <a:tailEnd type="none" w="med" len="med"/>
-                    </a:lnR>
-                    <a:lnT w="12700" cap="flat" cmpd="sng" algn="ctr">
-                      <a:solidFill>
-                        <a:srgbClr val="E3E8EC"/>
-                      </a:solidFill>
-                      <a:prstDash val="solid"/>
-                      <a:round/>
-                      <a:headEnd type="none" w="med" len="med"/>
-                      <a:tailEnd type="none" w="med" len="med"/>
-                    </a:lnT>
-                    <a:lnB w="12700" cap="flat" cmpd="sng" algn="ctr">
-                      <a:solidFill>
-                        <a:srgbClr val="E3E8EC"/>
-                      </a:solidFill>
-                      <a:prstDash val="solid"/>
-                      <a:round/>
-                      <a:headEnd type="none" w="med" len="med"/>
-                      <a:tailEnd type="none" w="med" len="med"/>
-                    </a:lnB>
-                    <a:solidFill>
-                      <a:srgbClr val="FFFFFF"/>
-                    </a:solidFill>
-                  </a:tcPr>
-                </a:tc>
-              </a:tr>
-              <a:tr h="420624">
-                <a:tc>
-                  <a:txBody>
-                    <a:bodyPr/>
-                    <a:lstStyle/>
-                    <a:p>
-                      <a:pPr algn="l" indent="0" marL="0">
-                        <a:buNone/>
-                      </a:pPr>
-                      <a:r>
-                        <a:rPr lang="en-US" sz="1300" b="1" dirty="0">
-                          <a:solidFill>
-                            <a:srgbClr val="14202E"/>
-                          </a:solidFill>
-                          <a:latin typeface="Calibri" pitchFamily="34" charset="0"/>
-                          <a:ea typeface="Calibri" pitchFamily="34" charset="-122"/>
-                          <a:cs typeface="Calibri" pitchFamily="34" charset="-120"/>
-                        </a:rPr>
-                        <a:t>Round-robin</a:t>
-                      </a:r>
-                      <a:endParaRPr lang="en-US" sz="1300" dirty="0">
-                        <a:latin typeface="Calibri" charset="0"/>
-                        <a:ea typeface="Calibri" charset="0"/>
-                        <a:cs typeface="Calibri" charset="0"/>
-                      </a:endParaRPr>
-                    </a:p>
-                  </a:txBody>
-                  <a:tcPr marL="91440" marR="91440" marT="45720" marB="45720" anchor="ctr">
-                    <a:lnL w="12700" cap="flat" cmpd="sng" algn="ctr">
-                      <a:solidFill>
-                        <a:srgbClr val="E3E8EC"/>
-                      </a:solidFill>
-                      <a:prstDash val="solid"/>
-                      <a:round/>
-                      <a:headEnd type="none" w="med" len="med"/>
-                      <a:tailEnd type="none" w="med" len="med"/>
-                    </a:lnL>
-                    <a:lnR w="12700" cap="flat" cmpd="sng" algn="ctr">
-                      <a:solidFill>
-                        <a:srgbClr val="E3E8EC"/>
-                      </a:solidFill>
-                      <a:prstDash val="solid"/>
-                      <a:round/>
-                      <a:headEnd type="none" w="med" len="med"/>
-                      <a:tailEnd type="none" w="med" len="med"/>
-                    </a:lnR>
-                    <a:lnT w="12700" cap="flat" cmpd="sng" algn="ctr">
-                      <a:solidFill>
-                        <a:srgbClr val="E3E8EC"/>
-                      </a:solidFill>
-                      <a:prstDash val="solid"/>
-                      <a:round/>
-                      <a:headEnd type="none" w="med" len="med"/>
-                      <a:tailEnd type="none" w="med" len="med"/>
-                    </a:lnT>
-                    <a:lnB w="12700" cap="flat" cmpd="sng" algn="ctr">
-                      <a:solidFill>
-                        <a:srgbClr val="E3E8EC"/>
-                      </a:solidFill>
-                      <a:prstDash val="solid"/>
-                      <a:round/>
-                      <a:headEnd type="none" w="med" len="med"/>
-                      <a:tailEnd type="none" w="med" len="med"/>
-                    </a:lnB>
-                    <a:solidFill>
-                      <a:srgbClr val="EDF1F4"/>
-                    </a:solidFill>
-                  </a:tcPr>
-                </a:tc>
-                <a:tc>
-                  <a:txBody>
-                    <a:bodyPr/>
-                    <a:lstStyle/>
-                    <a:p>
-                      <a:pPr algn="ctr" indent="0" marL="0">
-                        <a:buNone/>
-                      </a:pPr>
-                      <a:r>
-                        <a:rPr lang="en-US" sz="1300" dirty="0">
-                          <a:solidFill>
-                            <a:srgbClr val="14202E"/>
-                          </a:solidFill>
-                          <a:latin typeface="Calibri" pitchFamily="34" charset="0"/>
-                          <a:ea typeface="Calibri" pitchFamily="34" charset="-122"/>
-                          <a:cs typeface="Calibri" pitchFamily="34" charset="-120"/>
-                        </a:rPr>
-                        <a:t>4.01×</a:t>
-                      </a:r>
-                      <a:endParaRPr lang="en-US" sz="1300" dirty="0">
-                        <a:latin typeface="Calibri" charset="0"/>
-                        <a:ea typeface="Calibri" charset="0"/>
-                        <a:cs typeface="Calibri" charset="0"/>
-                      </a:endParaRPr>
-                    </a:p>
-                  </a:txBody>
-                  <a:tcPr marL="91440" marR="91440" marT="45720" marB="45720" anchor="ctr">
-                    <a:lnL w="12700" cap="flat" cmpd="sng" algn="ctr">
-                      <a:solidFill>
-                        <a:srgbClr val="E3E8EC"/>
-                      </a:solidFill>
-                      <a:prstDash val="solid"/>
-                      <a:round/>
-                      <a:headEnd type="none" w="med" len="med"/>
-                      <a:tailEnd type="none" w="med" len="med"/>
-                    </a:lnL>
-                    <a:lnR w="12700" cap="flat" cmpd="sng" algn="ctr">
-                      <a:solidFill>
-                        <a:srgbClr val="E3E8EC"/>
-                      </a:solidFill>
-                      <a:prstDash val="solid"/>
-                      <a:round/>
-                      <a:headEnd type="none" w="med" len="med"/>
-                      <a:tailEnd type="none" w="med" len="med"/>
-                    </a:lnR>
-                    <a:lnT w="12700" cap="flat" cmpd="sng" algn="ctr">
-                      <a:solidFill>
-                        <a:srgbClr val="E3E8EC"/>
-                      </a:solidFill>
-                      <a:prstDash val="solid"/>
-                      <a:round/>
-                      <a:headEnd type="none" w="med" len="med"/>
-                      <a:tailEnd type="none" w="med" len="med"/>
-                    </a:lnT>
-                    <a:lnB w="12700" cap="flat" cmpd="sng" algn="ctr">
-                      <a:solidFill>
-                        <a:srgbClr val="E3E8EC"/>
-                      </a:solidFill>
-                      <a:prstDash val="solid"/>
-                      <a:round/>
-                      <a:headEnd type="none" w="med" len="med"/>
-                      <a:tailEnd type="none" w="med" len="med"/>
-                    </a:lnB>
-                    <a:solidFill>
-                      <a:srgbClr val="EDF1F4"/>
-                    </a:solidFill>
-                  </a:tcPr>
-                </a:tc>
-                <a:tc>
-                  <a:txBody>
-                    <a:bodyPr/>
-                    <a:lstStyle/>
-                    <a:p>
-                      <a:pPr algn="ctr" indent="0" marL="0">
-                        <a:buNone/>
-                      </a:pPr>
-                      <a:r>
-                        <a:rPr lang="en-US" sz="1300" dirty="0">
-                          <a:solidFill>
-                            <a:srgbClr val="14202E"/>
-                          </a:solidFill>
-                          <a:latin typeface="Calibri" pitchFamily="34" charset="0"/>
-                          <a:ea typeface="Calibri" pitchFamily="34" charset="-122"/>
-                          <a:cs typeface="Calibri" pitchFamily="34" charset="-120"/>
-                        </a:rPr>
-                        <a:t>4.35×</a:t>
-                      </a:r>
-                      <a:endParaRPr lang="en-US" sz="1300" dirty="0">
-                        <a:latin typeface="Calibri" charset="0"/>
-                        <a:ea typeface="Calibri" charset="0"/>
-                        <a:cs typeface="Calibri" charset="0"/>
-                      </a:endParaRPr>
-                    </a:p>
-                  </a:txBody>
-                  <a:tcPr marL="91440" marR="91440" marT="45720" marB="45720" anchor="ctr">
-                    <a:lnL w="12700" cap="flat" cmpd="sng" algn="ctr">
-                      <a:solidFill>
-                        <a:srgbClr val="E3E8EC"/>
-                      </a:solidFill>
-                      <a:prstDash val="solid"/>
-                      <a:round/>
-                      <a:headEnd type="none" w="med" len="med"/>
-                      <a:tailEnd type="none" w="med" len="med"/>
-                    </a:lnL>
-                    <a:lnR w="12700" cap="flat" cmpd="sng" algn="ctr">
-                      <a:solidFill>
-                        <a:srgbClr val="E3E8EC"/>
-                      </a:solidFill>
-                      <a:prstDash val="solid"/>
-                      <a:round/>
-                      <a:headEnd type="none" w="med" len="med"/>
-                      <a:tailEnd type="none" w="med" len="med"/>
-                    </a:lnR>
-                    <a:lnT w="12700" cap="flat" cmpd="sng" algn="ctr">
-                      <a:solidFill>
-                        <a:srgbClr val="E3E8EC"/>
-                      </a:solidFill>
-                      <a:prstDash val="solid"/>
-                      <a:round/>
-                      <a:headEnd type="none" w="med" len="med"/>
-                      <a:tailEnd type="none" w="med" len="med"/>
-                    </a:lnT>
-                    <a:lnB w="12700" cap="flat" cmpd="sng" algn="ctr">
-                      <a:solidFill>
-                        <a:srgbClr val="E3E8EC"/>
-                      </a:solidFill>
-                      <a:prstDash val="solid"/>
-                      <a:round/>
-                      <a:headEnd type="none" w="med" len="med"/>
-                      <a:tailEnd type="none" w="med" len="med"/>
-                    </a:lnB>
-                    <a:solidFill>
-                      <a:srgbClr val="EDF1F4"/>
-                    </a:solidFill>
-                  </a:tcPr>
-                </a:tc>
-                <a:tc>
-                  <a:txBody>
-                    <a:bodyPr/>
-                    <a:lstStyle/>
-                    <a:p>
-                      <a:pPr algn="ctr" indent="0" marL="0">
-                        <a:buNone/>
-                      </a:pPr>
-                      <a:r>
-                        <a:rPr lang="en-US" sz="1300" dirty="0">
-                          <a:solidFill>
-                            <a:srgbClr val="14202E"/>
-                          </a:solidFill>
-                          <a:latin typeface="Calibri" pitchFamily="34" charset="0"/>
-                          <a:ea typeface="Calibri" pitchFamily="34" charset="-122"/>
-                          <a:cs typeface="Calibri" pitchFamily="34" charset="-120"/>
-                        </a:rPr>
-                        <a:t>4.49×</a:t>
-                      </a:r>
-                      <a:endParaRPr lang="en-US" sz="1300" dirty="0">
-                        <a:latin typeface="Calibri" charset="0"/>
-                        <a:ea typeface="Calibri" charset="0"/>
-                        <a:cs typeface="Calibri" charset="0"/>
-                      </a:endParaRPr>
-                    </a:p>
-                  </a:txBody>
-                  <a:tcPr marL="91440" marR="91440" marT="45720" marB="45720" anchor="ctr">
-                    <a:lnL w="12700" cap="flat" cmpd="sng" algn="ctr">
-                      <a:solidFill>
-                        <a:srgbClr val="E3E8EC"/>
-                      </a:solidFill>
-                      <a:prstDash val="solid"/>
-                      <a:round/>
-                      <a:headEnd type="none" w="med" len="med"/>
-                      <a:tailEnd type="none" w="med" len="med"/>
-                    </a:lnL>
-                    <a:lnR w="12700" cap="flat" cmpd="sng" algn="ctr">
-                      <a:solidFill>
-                        <a:srgbClr val="E3E8EC"/>
-                      </a:solidFill>
-                      <a:prstDash val="solid"/>
-                      <a:round/>
-                      <a:headEnd type="none" w="med" len="med"/>
-                      <a:tailEnd type="none" w="med" len="med"/>
-                    </a:lnR>
-                    <a:lnT w="12700" cap="flat" cmpd="sng" algn="ctr">
-                      <a:solidFill>
-                        <a:srgbClr val="E3E8EC"/>
-                      </a:solidFill>
-                      <a:prstDash val="solid"/>
-                      <a:round/>
-                      <a:headEnd type="none" w="med" len="med"/>
-                      <a:tailEnd type="none" w="med" len="med"/>
-                    </a:lnT>
-                    <a:lnB w="12700" cap="flat" cmpd="sng" algn="ctr">
-                      <a:solidFill>
-                        <a:srgbClr val="E3E8EC"/>
-                      </a:solidFill>
-                      <a:prstDash val="solid"/>
-                      <a:round/>
-                      <a:headEnd type="none" w="med" len="med"/>
-                      <a:tailEnd type="none" w="med" len="med"/>
-                    </a:lnB>
-                    <a:solidFill>
-                      <a:srgbClr val="EDF1F4"/>
-                    </a:solidFill>
-                  </a:tcPr>
-                </a:tc>
-                <a:tc>
-                  <a:txBody>
-                    <a:bodyPr/>
-                    <a:lstStyle/>
-                    <a:p>
-                      <a:pPr algn="ctr" indent="0" marL="0">
-                        <a:buNone/>
-                      </a:pPr>
-                      <a:r>
-                        <a:rPr lang="en-US" sz="1300" b="1" dirty="0">
-                          <a:solidFill>
-                            <a:srgbClr val="F2A65A"/>
-                          </a:solidFill>
-                          <a:latin typeface="Calibri" pitchFamily="34" charset="0"/>
-                          <a:ea typeface="Calibri" pitchFamily="34" charset="-122"/>
-                          <a:cs typeface="Calibri" pitchFamily="34" charset="-120"/>
-                        </a:rPr>
-                        <a:t>4.28×</a:t>
-                      </a:r>
-                      <a:endParaRPr lang="en-US" sz="1300" dirty="0">
-                        <a:latin typeface="Calibri" charset="0"/>
-                        <a:ea typeface="Calibri" charset="0"/>
-                        <a:cs typeface="Calibri" charset="0"/>
-                      </a:endParaRPr>
-                    </a:p>
-                  </a:txBody>
-                  <a:tcPr marL="91440" marR="91440" marT="45720" marB="45720" anchor="ctr">
-                    <a:lnL w="12700" cap="flat" cmpd="sng" algn="ctr">
-                      <a:solidFill>
-                        <a:srgbClr val="E3E8EC"/>
-                      </a:solidFill>
-                      <a:prstDash val="solid"/>
-                      <a:round/>
-                      <a:headEnd type="none" w="med" len="med"/>
-                      <a:tailEnd type="none" w="med" len="med"/>
-                    </a:lnL>
-                    <a:lnR w="12700" cap="flat" cmpd="sng" algn="ctr">
-                      <a:solidFill>
-                        <a:srgbClr val="E3E8EC"/>
-                      </a:solidFill>
-                      <a:prstDash val="solid"/>
-                      <a:round/>
-                      <a:headEnd type="none" w="med" len="med"/>
-                      <a:tailEnd type="none" w="med" len="med"/>
-                    </a:lnR>
-                    <a:lnT w="12700" cap="flat" cmpd="sng" algn="ctr">
-                      <a:solidFill>
-                        <a:srgbClr val="E3E8EC"/>
-                      </a:solidFill>
-                      <a:prstDash val="solid"/>
-                      <a:round/>
-                      <a:headEnd type="none" w="med" len="med"/>
-                      <a:tailEnd type="none" w="med" len="med"/>
-                    </a:lnT>
-                    <a:lnB w="12700" cap="flat" cmpd="sng" algn="ctr">
-                      <a:solidFill>
-                        <a:srgbClr val="E3E8EC"/>
-                      </a:solidFill>
-                      <a:prstDash val="solid"/>
-                      <a:round/>
-                      <a:headEnd type="none" w="med" len="med"/>
-                      <a:tailEnd type="none" w="med" len="med"/>
-                    </a:lnB>
-                    <a:solidFill>
-                      <a:srgbClr val="EDF1F4"/>
-                    </a:solidFill>
-                  </a:tcPr>
-                </a:tc>
-              </a:tr>
-            </a:tbl>
-          </a:graphicData>
-        </a:graphic>
-      </p:graphicFrame>
-      <p:sp>
-        <p:nvSpPr>
-          <p:cNvPr id="6" name="Text 3"/>
-          <p:cNvSpPr/>
-          <p:nvPr/>
-        </p:nvSpPr>
-        <p:spPr>
-          <a:xfrm>
-            <a:off x="658368" y="3913632"/>
-            <a:ext cx="6949440" cy="685800"/>
+      <p:sp>
+        <p:nvSpPr>
+          <p:cNvPr id="5" name="Text 3"/>
+          <p:cNvSpPr/>
+          <p:nvPr/>
+        </p:nvSpPr>
+        <p:spPr>
+          <a:xfrm>
+            <a:off x="658368" y="2103120"/>
+            <a:ext cx="6949440" cy="274320"/>
+          </a:xfrm>
+          <a:prstGeom prst="rect">
+            <a:avLst/>
+          </a:prstGeom>
+          <a:noFill/>
+          <a:ln/>
+        </p:spPr>
+        <p:txBody>
+          <a:bodyPr wrap="square" lIns="0" tIns="0" rIns="0" bIns="0" rtlCol="0" anchor="ctr"/>
+          <a:lstStyle/>
+          <a:p>
+            <a:pPr indent="0" marL="0">
+              <a:buNone/>
+            </a:pPr>
+            <a:r>
+              <a:rPr lang="en-US" sz="1300" b="1" dirty="0">
+                <a:solidFill>
+                  <a:srgbClr val="14202E"/>
+                </a:solidFill>
+                <a:latin typeface="Calibri" pitchFamily="34" charset="0"/>
+                <a:ea typeface="Calibri" pitchFamily="34" charset="-122"/>
+                <a:cs typeface="Calibri" pitchFamily="34" charset="-120"/>
+              </a:rPr>
+              <a:t>El mismo código, sobre el mismo dato, 10 veces seguidas:</a:t>
+            </a:r>
+            <a:endParaRPr lang="en-US" sz="1300" dirty="0"/>
+          </a:p>
+        </p:txBody>
+      </p:sp>
+      <p:sp>
+        <p:nvSpPr>
+          <p:cNvPr id="6" name="Shape 4"/>
+          <p:cNvSpPr/>
+          <p:nvPr/>
+        </p:nvSpPr>
+        <p:spPr>
+          <a:xfrm>
+            <a:off x="640080" y="2450592"/>
+            <a:ext cx="7040880" cy="2286000"/>
+          </a:xfrm>
+          <a:prstGeom prst="roundRect">
+            <a:avLst>
+              <a:gd name="adj" fmla="val 3200"/>
+            </a:avLst>
+          </a:prstGeom>
+          <a:solidFill>
+            <a:srgbClr val="0B141F"/>
+          </a:solidFill>
+          <a:ln w="12700">
+            <a:solidFill>
+              <a:srgbClr val="0B141F"/>
+            </a:solidFill>
+            <a:prstDash val="solid"/>
+          </a:ln>
+          <a:effectLst>
+            <a:outerShdw sx="100000" sy="100000" kx="0" ky="0" algn="bl" rotWithShape="0" blurRad="127000" dist="25400" dir="5400000">
+              <a:srgbClr val="9AA9B8">
+                <a:alpha val="22000"/>
+              </a:srgbClr>
+            </a:outerShdw>
+          </a:effectLst>
+        </p:spPr>
+      </p:sp>
+      <p:sp>
+        <p:nvSpPr>
+          <p:cNvPr id="7" name="Text 5"/>
+          <p:cNvSpPr/>
+          <p:nvPr/>
+        </p:nvSpPr>
+        <p:spPr>
+          <a:xfrm>
+            <a:off x="914400" y="2651760"/>
+            <a:ext cx="457200" cy="274320"/>
+          </a:xfrm>
+          <a:prstGeom prst="rect">
+            <a:avLst/>
+          </a:prstGeom>
+          <a:noFill/>
+          <a:ln/>
+        </p:spPr>
+        <p:txBody>
+          <a:bodyPr wrap="square" lIns="0" tIns="0" rIns="0" bIns="0" rtlCol="0" anchor="ctr"/>
+          <a:lstStyle/>
+          <a:p>
+            <a:pPr indent="0" marL="0">
+              <a:buNone/>
+            </a:pPr>
+            <a:r>
+              <a:rPr lang="en-US" sz="1300" b="1" dirty="0">
+                <a:solidFill>
+                  <a:srgbClr val="E94F4F"/>
+                </a:solidFill>
+                <a:latin typeface="Courier New" pitchFamily="34" charset="0"/>
+                <a:ea typeface="Courier New" pitchFamily="34" charset="-122"/>
+                <a:cs typeface="Courier New" pitchFamily="34" charset="-120"/>
+              </a:rPr>
+              <a:t>#1</a:t>
+            </a:r>
+            <a:endParaRPr lang="en-US" sz="1300" dirty="0"/>
+          </a:p>
+        </p:txBody>
+      </p:sp>
+      <p:sp>
+        <p:nvSpPr>
+          <p:cNvPr id="8" name="Text 6"/>
+          <p:cNvSpPr/>
+          <p:nvPr/>
+        </p:nvSpPr>
+        <p:spPr>
+          <a:xfrm>
+            <a:off x="1417320" y="2651760"/>
+            <a:ext cx="1188720" cy="274320"/>
+          </a:xfrm>
+          <a:prstGeom prst="rect">
+            <a:avLst/>
+          </a:prstGeom>
+          <a:noFill/>
+          <a:ln/>
+        </p:spPr>
+        <p:txBody>
+          <a:bodyPr wrap="square" lIns="0" tIns="0" rIns="0" bIns="0" rtlCol="0" anchor="ctr"/>
+          <a:lstStyle/>
+          <a:p>
+            <a:pPr indent="0" marL="0">
+              <a:buNone/>
+            </a:pPr>
+            <a:r>
+              <a:rPr lang="en-US" sz="1300" b="1" dirty="0">
+                <a:solidFill>
+                  <a:srgbClr val="E94F4F"/>
+                </a:solidFill>
+                <a:latin typeface="Courier New" pitchFamily="34" charset="0"/>
+                <a:ea typeface="Courier New" pitchFamily="34" charset="-122"/>
+                <a:cs typeface="Courier New" pitchFamily="34" charset="-120"/>
+              </a:rPr>
+              <a:t>0.1622 s</a:t>
+            </a:r>
+            <a:endParaRPr lang="en-US" sz="1300" dirty="0"/>
+          </a:p>
+        </p:txBody>
+      </p:sp>
+      <p:sp>
+        <p:nvSpPr>
+          <p:cNvPr id="9" name="Text 7"/>
+          <p:cNvSpPr/>
+          <p:nvPr/>
+        </p:nvSpPr>
+        <p:spPr>
+          <a:xfrm>
+            <a:off x="2743200" y="2651760"/>
+            <a:ext cx="3931920" cy="274320"/>
+          </a:xfrm>
+          <a:prstGeom prst="rect">
+            <a:avLst/>
+          </a:prstGeom>
+          <a:noFill/>
+          <a:ln/>
+        </p:spPr>
+        <p:txBody>
+          <a:bodyPr wrap="square" lIns="0" tIns="0" rIns="0" bIns="0" rtlCol="0" anchor="ctr"/>
+          <a:lstStyle/>
+          <a:p>
+            <a:pPr indent="0" marL="0">
+              <a:buNone/>
+            </a:pPr>
+            <a:r>
+              <a:rPr lang="en-US" sz="1200" b="1" dirty="0">
+                <a:solidFill>
+                  <a:srgbClr val="E94F4F"/>
+                </a:solidFill>
+                <a:latin typeface="Calibri" pitchFamily="34" charset="0"/>
+                <a:ea typeface="Calibri" pitchFamily="34" charset="-122"/>
+                <a:cs typeface="Calibri" pitchFamily="34" charset="-120"/>
+              </a:rPr>
+              <a:t>← la única que medía el programa</a:t>
+            </a:r>
+            <a:endParaRPr lang="en-US" sz="1200" dirty="0"/>
+          </a:p>
+        </p:txBody>
+      </p:sp>
+      <p:sp>
+        <p:nvSpPr>
+          <p:cNvPr id="10" name="Text 8"/>
+          <p:cNvSpPr/>
+          <p:nvPr/>
+        </p:nvSpPr>
+        <p:spPr>
+          <a:xfrm>
+            <a:off x="914400" y="3054096"/>
+            <a:ext cx="457200" cy="274320"/>
+          </a:xfrm>
+          <a:prstGeom prst="rect">
+            <a:avLst/>
+          </a:prstGeom>
+          <a:noFill/>
+          <a:ln/>
+        </p:spPr>
+        <p:txBody>
+          <a:bodyPr wrap="square" lIns="0" tIns="0" rIns="0" bIns="0" rtlCol="0" anchor="ctr"/>
+          <a:lstStyle/>
+          <a:p>
+            <a:pPr indent="0" marL="0">
+              <a:buNone/>
+            </a:pPr>
+            <a:r>
+              <a:rPr lang="en-US" sz="1300" dirty="0">
+                <a:solidFill>
+                  <a:srgbClr val="9BB0C4"/>
+                </a:solidFill>
+                <a:latin typeface="Courier New" pitchFamily="34" charset="0"/>
+                <a:ea typeface="Courier New" pitchFamily="34" charset="-122"/>
+                <a:cs typeface="Courier New" pitchFamily="34" charset="-120"/>
+              </a:rPr>
+              <a:t>#2</a:t>
+            </a:r>
+            <a:endParaRPr lang="en-US" sz="1300" dirty="0"/>
+          </a:p>
+        </p:txBody>
+      </p:sp>
+      <p:sp>
+        <p:nvSpPr>
+          <p:cNvPr id="11" name="Text 9"/>
+          <p:cNvSpPr/>
+          <p:nvPr/>
+        </p:nvSpPr>
+        <p:spPr>
+          <a:xfrm>
+            <a:off x="1417320" y="3054096"/>
+            <a:ext cx="1188720" cy="274320"/>
+          </a:xfrm>
+          <a:prstGeom prst="rect">
+            <a:avLst/>
+          </a:prstGeom>
+          <a:noFill/>
+          <a:ln/>
+        </p:spPr>
+        <p:txBody>
+          <a:bodyPr wrap="square" lIns="0" tIns="0" rIns="0" bIns="0" rtlCol="0" anchor="ctr"/>
+          <a:lstStyle/>
+          <a:p>
+            <a:pPr indent="0" marL="0">
+              <a:buNone/>
+            </a:pPr>
+            <a:r>
+              <a:rPr lang="en-US" sz="1300" dirty="0">
+                <a:solidFill>
+                  <a:srgbClr val="02C39A"/>
+                </a:solidFill>
+                <a:latin typeface="Courier New" pitchFamily="34" charset="0"/>
+                <a:ea typeface="Courier New" pitchFamily="34" charset="-122"/>
+                <a:cs typeface="Courier New" pitchFamily="34" charset="-120"/>
+              </a:rPr>
+              <a:t>0.1082 s</a:t>
+            </a:r>
+            <a:endParaRPr lang="en-US" sz="1300" dirty="0"/>
+          </a:p>
+        </p:txBody>
+      </p:sp>
+      <p:sp>
+        <p:nvSpPr>
+          <p:cNvPr id="12" name="Text 10"/>
+          <p:cNvSpPr/>
+          <p:nvPr/>
+        </p:nvSpPr>
+        <p:spPr>
+          <a:xfrm>
+            <a:off x="914400" y="3456432"/>
+            <a:ext cx="457200" cy="274320"/>
+          </a:xfrm>
+          <a:prstGeom prst="rect">
+            <a:avLst/>
+          </a:prstGeom>
+          <a:noFill/>
+          <a:ln/>
+        </p:spPr>
+        <p:txBody>
+          <a:bodyPr wrap="square" lIns="0" tIns="0" rIns="0" bIns="0" rtlCol="0" anchor="ctr"/>
+          <a:lstStyle/>
+          <a:p>
+            <a:pPr indent="0" marL="0">
+              <a:buNone/>
+            </a:pPr>
+            <a:r>
+              <a:rPr lang="en-US" sz="1300" dirty="0">
+                <a:solidFill>
+                  <a:srgbClr val="9BB0C4"/>
+                </a:solidFill>
+                <a:latin typeface="Courier New" pitchFamily="34" charset="0"/>
+                <a:ea typeface="Courier New" pitchFamily="34" charset="-122"/>
+                <a:cs typeface="Courier New" pitchFamily="34" charset="-120"/>
+              </a:rPr>
+              <a:t>#3</a:t>
+            </a:r>
+            <a:endParaRPr lang="en-US" sz="1300" dirty="0"/>
+          </a:p>
+        </p:txBody>
+      </p:sp>
+      <p:sp>
+        <p:nvSpPr>
+          <p:cNvPr id="13" name="Text 11"/>
+          <p:cNvSpPr/>
+          <p:nvPr/>
+        </p:nvSpPr>
+        <p:spPr>
+          <a:xfrm>
+            <a:off x="1417320" y="3456432"/>
+            <a:ext cx="1188720" cy="274320"/>
+          </a:xfrm>
+          <a:prstGeom prst="rect">
+            <a:avLst/>
+          </a:prstGeom>
+          <a:noFill/>
+          <a:ln/>
+        </p:spPr>
+        <p:txBody>
+          <a:bodyPr wrap="square" lIns="0" tIns="0" rIns="0" bIns="0" rtlCol="0" anchor="ctr"/>
+          <a:lstStyle/>
+          <a:p>
+            <a:pPr indent="0" marL="0">
+              <a:buNone/>
+            </a:pPr>
+            <a:r>
+              <a:rPr lang="en-US" sz="1300" dirty="0">
+                <a:solidFill>
+                  <a:srgbClr val="02C39A"/>
+                </a:solidFill>
+                <a:latin typeface="Courier New" pitchFamily="34" charset="0"/>
+                <a:ea typeface="Courier New" pitchFamily="34" charset="-122"/>
+                <a:cs typeface="Courier New" pitchFamily="34" charset="-120"/>
+              </a:rPr>
+              <a:t>0.1133 s</a:t>
+            </a:r>
+            <a:endParaRPr lang="en-US" sz="1300" dirty="0"/>
+          </a:p>
+        </p:txBody>
+      </p:sp>
+      <p:sp>
+        <p:nvSpPr>
+          <p:cNvPr id="14" name="Text 12"/>
+          <p:cNvSpPr/>
+          <p:nvPr/>
+        </p:nvSpPr>
+        <p:spPr>
+          <a:xfrm>
+            <a:off x="914400" y="3858768"/>
+            <a:ext cx="457200" cy="274320"/>
+          </a:xfrm>
+          <a:prstGeom prst="rect">
+            <a:avLst/>
+          </a:prstGeom>
+          <a:noFill/>
+          <a:ln/>
+        </p:spPr>
+        <p:txBody>
+          <a:bodyPr wrap="square" lIns="0" tIns="0" rIns="0" bIns="0" rtlCol="0" anchor="ctr"/>
+          <a:lstStyle/>
+          <a:p>
+            <a:pPr indent="0" marL="0">
+              <a:buNone/>
+            </a:pPr>
+            <a:r>
+              <a:rPr lang="en-US" sz="1300" dirty="0">
+                <a:solidFill>
+                  <a:srgbClr val="9BB0C4"/>
+                </a:solidFill>
+                <a:latin typeface="Courier New" pitchFamily="34" charset="0"/>
+                <a:ea typeface="Courier New" pitchFamily="34" charset="-122"/>
+                <a:cs typeface="Courier New" pitchFamily="34" charset="-120"/>
+              </a:rPr>
+              <a:t>#4</a:t>
+            </a:r>
+            <a:endParaRPr lang="en-US" sz="1300" dirty="0"/>
+          </a:p>
+        </p:txBody>
+      </p:sp>
+      <p:sp>
+        <p:nvSpPr>
+          <p:cNvPr id="15" name="Text 13"/>
+          <p:cNvSpPr/>
+          <p:nvPr/>
+        </p:nvSpPr>
+        <p:spPr>
+          <a:xfrm>
+            <a:off x="1417320" y="3858768"/>
+            <a:ext cx="1188720" cy="274320"/>
+          </a:xfrm>
+          <a:prstGeom prst="rect">
+            <a:avLst/>
+          </a:prstGeom>
+          <a:noFill/>
+          <a:ln/>
+        </p:spPr>
+        <p:txBody>
+          <a:bodyPr wrap="square" lIns="0" tIns="0" rIns="0" bIns="0" rtlCol="0" anchor="ctr"/>
+          <a:lstStyle/>
+          <a:p>
+            <a:pPr indent="0" marL="0">
+              <a:buNone/>
+            </a:pPr>
+            <a:r>
+              <a:rPr lang="en-US" sz="1300" dirty="0">
+                <a:solidFill>
+                  <a:srgbClr val="02C39A"/>
+                </a:solidFill>
+                <a:latin typeface="Courier New" pitchFamily="34" charset="0"/>
+                <a:ea typeface="Courier New" pitchFamily="34" charset="-122"/>
+                <a:cs typeface="Courier New" pitchFamily="34" charset="-120"/>
+              </a:rPr>
+              <a:t>0.1135 s</a:t>
+            </a:r>
+            <a:endParaRPr lang="en-US" sz="1300" dirty="0"/>
+          </a:p>
+        </p:txBody>
+      </p:sp>
+      <p:sp>
+        <p:nvSpPr>
+          <p:cNvPr id="16" name="Text 14"/>
+          <p:cNvSpPr/>
+          <p:nvPr/>
+        </p:nvSpPr>
+        <p:spPr>
+          <a:xfrm>
+            <a:off x="914400" y="4261104"/>
+            <a:ext cx="457200" cy="274320"/>
+          </a:xfrm>
+          <a:prstGeom prst="rect">
+            <a:avLst/>
+          </a:prstGeom>
+          <a:noFill/>
+          <a:ln/>
+        </p:spPr>
+        <p:txBody>
+          <a:bodyPr wrap="square" lIns="0" tIns="0" rIns="0" bIns="0" rtlCol="0" anchor="ctr"/>
+          <a:lstStyle/>
+          <a:p>
+            <a:pPr indent="0" marL="0">
+              <a:buNone/>
+            </a:pPr>
+            <a:r>
+              <a:rPr lang="en-US" sz="1300" dirty="0">
+                <a:solidFill>
+                  <a:srgbClr val="9BB0C4"/>
+                </a:solidFill>
+                <a:latin typeface="Courier New" pitchFamily="34" charset="0"/>
+                <a:ea typeface="Courier New" pitchFamily="34" charset="-122"/>
+                <a:cs typeface="Courier New" pitchFamily="34" charset="-120"/>
+              </a:rPr>
+              <a:t>#5</a:t>
+            </a:r>
+            <a:endParaRPr lang="en-US" sz="1300" dirty="0"/>
+          </a:p>
+        </p:txBody>
+      </p:sp>
+      <p:sp>
+        <p:nvSpPr>
+          <p:cNvPr id="17" name="Text 15"/>
+          <p:cNvSpPr/>
+          <p:nvPr/>
+        </p:nvSpPr>
+        <p:spPr>
+          <a:xfrm>
+            <a:off x="1417320" y="4261104"/>
+            <a:ext cx="1188720" cy="274320"/>
+          </a:xfrm>
+          <a:prstGeom prst="rect">
+            <a:avLst/>
+          </a:prstGeom>
+          <a:noFill/>
+          <a:ln/>
+        </p:spPr>
+        <p:txBody>
+          <a:bodyPr wrap="square" lIns="0" tIns="0" rIns="0" bIns="0" rtlCol="0" anchor="ctr"/>
+          <a:lstStyle/>
+          <a:p>
+            <a:pPr indent="0" marL="0">
+              <a:buNone/>
+            </a:pPr>
+            <a:r>
+              <a:rPr lang="en-US" sz="1300" dirty="0">
+                <a:solidFill>
+                  <a:srgbClr val="02C39A"/>
+                </a:solidFill>
+                <a:latin typeface="Courier New" pitchFamily="34" charset="0"/>
+                <a:ea typeface="Courier New" pitchFamily="34" charset="-122"/>
+                <a:cs typeface="Courier New" pitchFamily="34" charset="-120"/>
+              </a:rPr>
+              <a:t>0.1090 s</a:t>
+            </a:r>
+            <a:endParaRPr lang="en-US" sz="1300" dirty="0"/>
+          </a:p>
+        </p:txBody>
+      </p:sp>
+      <p:sp>
+        <p:nvSpPr>
+          <p:cNvPr id="18" name="Text 16"/>
+          <p:cNvSpPr/>
+          <p:nvPr/>
+        </p:nvSpPr>
+        <p:spPr>
+          <a:xfrm>
+            <a:off x="658368" y="4892040"/>
+            <a:ext cx="7040880" cy="731520"/>
           </a:xfrm>
           <a:prstGeom prst="rect">
             <a:avLst/>
@@ -11899,12 +10661,12 @@
           <a:p>
             <a:pPr indent="0" marL="0">
               <a:lnSpc>
-                <a:spcPts val="1900"/>
+                <a:spcPts val="1800"/>
               </a:lnSpc>
               <a:buNone/>
             </a:pPr>
             <a:r>
-              <a:rPr lang="en-US" sz="1350" dirty="0">
+              <a:rPr lang="en-US" sz="1300" dirty="0">
                 <a:solidFill>
                   <a:srgbClr val="5A6B7D"/>
                 </a:solidFill>
@@ -11912,22 +10674,22 @@
                 <a:ea typeface="Calibri" pitchFamily="34" charset="-122"/>
                 <a:cs typeface="Calibri" pitchFamily="34" charset="-120"/>
               </a:rPr>
-              <a:t>Las tres primeras quedan empatadas dentro del margen de ruido: la diferencia entre 6.30× y 6.06× no es una diferencia real.</a:t>
-            </a:r>
-            <a:endParaRPr lang="en-US" sz="1350" dirty="0"/>
-          </a:p>
-        </p:txBody>
-      </p:sp>
-      <p:sp>
-        <p:nvSpPr>
-          <p:cNvPr id="7" name="Shape 4"/>
-          <p:cNvSpPr/>
-          <p:nvPr/>
-        </p:nvSpPr>
-        <p:spPr>
-          <a:xfrm>
-            <a:off x="8001000" y="1627632"/>
-            <a:ext cx="3547872" cy="3977640"/>
+              <a:t>La primera ejecución es 50 % más lenta: .NET compila por niveles y aún no había optimizado el código. Como era el baseline, inflaba el speedup de todo lo demás.</a:t>
+            </a:r>
+            <a:endParaRPr lang="en-US" sz="1300" dirty="0"/>
+          </a:p>
+        </p:txBody>
+      </p:sp>
+      <p:sp>
+        <p:nvSpPr>
+          <p:cNvPr id="19" name="Shape 17"/>
+          <p:cNvSpPr/>
+          <p:nvPr/>
+        </p:nvSpPr>
+        <p:spPr>
+          <a:xfrm>
+            <a:off x="8001000" y="1170432"/>
+            <a:ext cx="3547872" cy="4480560"/>
           </a:xfrm>
           <a:prstGeom prst="roundRect">
             <a:avLst>
@@ -11954,30 +10716,30 @@
       </p:sp>
       <p:sp>
         <p:nvSpPr>
-          <p:cNvPr id="8" name="Text 5"/>
-          <p:cNvSpPr/>
-          <p:nvPr/>
-        </p:nvSpPr>
-        <p:spPr>
-          <a:xfrm>
-            <a:off x="8321040" y="1938528"/>
-            <a:ext cx="2926080" cy="320040"/>
-          </a:xfrm>
-          <a:prstGeom prst="rect">
-            <a:avLst/>
-          </a:prstGeom>
-          <a:noFill/>
-          <a:ln/>
-        </p:spPr>
-        <p:txBody>
-          <a:bodyPr wrap="square" lIns="0" tIns="0" rIns="0" bIns="0" rtlCol="0" anchor="ctr"/>
-          <a:lstStyle/>
-          <a:p>
-            <a:pPr indent="0" marL="0">
-              <a:buNone/>
-            </a:pPr>
-            <a:r>
-              <a:rPr lang="en-US" sz="1500" b="1" dirty="0">
+          <p:cNvPr id="20" name="Text 18"/>
+          <p:cNvSpPr/>
+          <p:nvPr/>
+        </p:nvSpPr>
+        <p:spPr>
+          <a:xfrm>
+            <a:off x="8321040" y="1481328"/>
+            <a:ext cx="2926080" cy="274320"/>
+          </a:xfrm>
+          <a:prstGeom prst="rect">
+            <a:avLst/>
+          </a:prstGeom>
+          <a:noFill/>
+          <a:ln/>
+        </p:spPr>
+        <p:txBody>
+          <a:bodyPr wrap="square" lIns="0" tIns="0" rIns="0" bIns="0" rtlCol="0" anchor="ctr"/>
+          <a:lstStyle/>
+          <a:p>
+            <a:pPr indent="0" marL="0">
+              <a:buNone/>
+            </a:pPr>
+            <a:r>
+              <a:rPr lang="en-US" sz="1100" b="1" spc="150" kern="0" dirty="0">
                 <a:solidFill>
                   <a:srgbClr val="02C39A"/>
                 </a:solidFill>
@@ -11985,42 +10747,233 @@
                 <a:ea typeface="Calibri" pitchFamily="34" charset="-122"/>
                 <a:cs typeface="Calibri" pitchFamily="34" charset="-120"/>
               </a:rPr>
-              <a:t>Lo que sí se sostiene</a:t>
-            </a:r>
-            <a:endParaRPr lang="en-US" sz="1500" dirty="0"/>
-          </a:p>
-        </p:txBody>
-      </p:sp>
-      <p:sp>
-        <p:nvSpPr>
-          <p:cNvPr id="9" name="Text 6"/>
-          <p:cNvSpPr/>
-          <p:nvPr/>
-        </p:nvSpPr>
-        <p:spPr>
-          <a:xfrm>
-            <a:off x="8321040" y="2395728"/>
-            <a:ext cx="2926080" cy="2834640"/>
-          </a:xfrm>
-          <a:prstGeom prst="rect">
-            <a:avLst/>
-          </a:prstGeom>
-          <a:noFill/>
-          <a:ln/>
-        </p:spPr>
-        <p:txBody>
-          <a:bodyPr wrap="square" lIns="0" tIns="0" rIns="0" bIns="0" rtlCol="0" anchor="ctr"/>
-          <a:lstStyle/>
-          <a:p>
-            <a:pPr marL="342900" indent="-342900">
+              <a:t>AL CORREGIRLO</a:t>
+            </a:r>
+            <a:endParaRPr lang="en-US" sz="1100" dirty="0"/>
+          </a:p>
+        </p:txBody>
+      </p:sp>
+      <p:sp>
+        <p:nvSpPr>
+          <p:cNvPr id="21" name="Text 19"/>
+          <p:cNvSpPr/>
+          <p:nvPr/>
+        </p:nvSpPr>
+        <p:spPr>
+          <a:xfrm>
+            <a:off x="8321040" y="1874520"/>
+            <a:ext cx="2926080" cy="274320"/>
+          </a:xfrm>
+          <a:prstGeom prst="rect">
+            <a:avLst/>
+          </a:prstGeom>
+          <a:noFill/>
+          <a:ln/>
+        </p:spPr>
+        <p:txBody>
+          <a:bodyPr wrap="square" lIns="0" tIns="0" rIns="0" bIns="0" rtlCol="0" anchor="ctr"/>
+          <a:lstStyle/>
+          <a:p>
+            <a:pPr indent="0" marL="0">
+              <a:buNone/>
+            </a:pPr>
+            <a:r>
+              <a:rPr lang="en-US" sz="1300" b="1" dirty="0">
+                <a:solidFill>
+                  <a:srgbClr val="FFFFFF"/>
+                </a:solidFill>
+                <a:latin typeface="Calibri" pitchFamily="34" charset="0"/>
+                <a:ea typeface="Calibri" pitchFamily="34" charset="-122"/>
+                <a:cs typeface="Calibri" pitchFamily="34" charset="-120"/>
+              </a:rPr>
+              <a:t>Eficiencia con 1 hilo</a:t>
+            </a:r>
+            <a:endParaRPr lang="en-US" sz="1300" dirty="0"/>
+          </a:p>
+        </p:txBody>
+      </p:sp>
+      <p:sp>
+        <p:nvSpPr>
+          <p:cNvPr id="22" name="Text 20"/>
+          <p:cNvSpPr/>
+          <p:nvPr/>
+        </p:nvSpPr>
+        <p:spPr>
+          <a:xfrm>
+            <a:off x="8321040" y="2212848"/>
+            <a:ext cx="2926080" cy="548640"/>
+          </a:xfrm>
+          <a:prstGeom prst="rect">
+            <a:avLst/>
+          </a:prstGeom>
+          <a:noFill/>
+          <a:ln/>
+        </p:spPr>
+        <p:txBody>
+          <a:bodyPr wrap="square" lIns="0" tIns="0" rIns="0" bIns="0" rtlCol="0" anchor="ctr"/>
+          <a:lstStyle/>
+          <a:p>
+            <a:pPr indent="0" marL="0">
+              <a:buNone/>
+            </a:pPr>
+            <a:r>
+              <a:rPr lang="en-US" sz="3000" b="1" dirty="0">
+                <a:solidFill>
+                  <a:srgbClr val="E94F4F"/>
+                </a:solidFill>
+                <a:latin typeface="Cambria" pitchFamily="34" charset="0"/>
+                <a:ea typeface="Cambria" pitchFamily="34" charset="-122"/>
+                <a:cs typeface="Cambria" pitchFamily="34" charset="-120"/>
+              </a:rPr>
+              <a:t>172 %</a:t>
+            </a:r>
+            <a:endParaRPr lang="en-US" sz="3000" dirty="0"/>
+          </a:p>
+        </p:txBody>
+      </p:sp>
+      <p:sp>
+        <p:nvSpPr>
+          <p:cNvPr id="23" name="Text 21"/>
+          <p:cNvSpPr/>
+          <p:nvPr/>
+        </p:nvSpPr>
+        <p:spPr>
+          <a:xfrm>
+            <a:off x="8321040" y="2743200"/>
+            <a:ext cx="2926080" cy="256032"/>
+          </a:xfrm>
+          <a:prstGeom prst="rect">
+            <a:avLst/>
+          </a:prstGeom>
+          <a:noFill/>
+          <a:ln/>
+        </p:spPr>
+        <p:txBody>
+          <a:bodyPr wrap="square" lIns="0" tIns="0" rIns="0" bIns="0" rtlCol="0" anchor="ctr"/>
+          <a:lstStyle/>
+          <a:p>
+            <a:pPr indent="0" marL="0">
+              <a:buNone/>
+            </a:pPr>
+            <a:r>
+              <a:rPr lang="en-US" sz="1100" dirty="0">
+                <a:solidFill>
+                  <a:srgbClr val="9BB0C4"/>
+                </a:solidFill>
+                <a:latin typeface="Calibri" pitchFamily="34" charset="0"/>
+                <a:ea typeface="Calibri" pitchFamily="34" charset="-122"/>
+                <a:cs typeface="Calibri" pitchFamily="34" charset="-120"/>
+              </a:rPr>
+              <a:t>antes  ·  imposible</a:t>
+            </a:r>
+            <a:endParaRPr lang="en-US" sz="1100" dirty="0"/>
+          </a:p>
+        </p:txBody>
+      </p:sp>
+      <p:sp>
+        <p:nvSpPr>
+          <p:cNvPr id="24" name="Text 22"/>
+          <p:cNvSpPr/>
+          <p:nvPr/>
+        </p:nvSpPr>
+        <p:spPr>
+          <a:xfrm>
+            <a:off x="8321040" y="3127248"/>
+            <a:ext cx="2926080" cy="548640"/>
+          </a:xfrm>
+          <a:prstGeom prst="rect">
+            <a:avLst/>
+          </a:prstGeom>
+          <a:noFill/>
+          <a:ln/>
+        </p:spPr>
+        <p:txBody>
+          <a:bodyPr wrap="square" lIns="0" tIns="0" rIns="0" bIns="0" rtlCol="0" anchor="ctr"/>
+          <a:lstStyle/>
+          <a:p>
+            <a:pPr indent="0" marL="0">
+              <a:buNone/>
+            </a:pPr>
+            <a:r>
+              <a:rPr lang="en-US" sz="3000" b="1" dirty="0">
+                <a:solidFill>
+                  <a:srgbClr val="02C39A"/>
+                </a:solidFill>
+                <a:latin typeface="Cambria" pitchFamily="34" charset="0"/>
+                <a:ea typeface="Cambria" pitchFamily="34" charset="-122"/>
+                <a:cs typeface="Cambria" pitchFamily="34" charset="-120"/>
+              </a:rPr>
+              <a:t>100 %</a:t>
+            </a:r>
+            <a:endParaRPr lang="en-US" sz="3000" dirty="0"/>
+          </a:p>
+        </p:txBody>
+      </p:sp>
+      <p:sp>
+        <p:nvSpPr>
+          <p:cNvPr id="25" name="Text 23"/>
+          <p:cNvSpPr/>
+          <p:nvPr/>
+        </p:nvSpPr>
+        <p:spPr>
+          <a:xfrm>
+            <a:off x="8321040" y="3657600"/>
+            <a:ext cx="2926080" cy="256032"/>
+          </a:xfrm>
+          <a:prstGeom prst="rect">
+            <a:avLst/>
+          </a:prstGeom>
+          <a:noFill/>
+          <a:ln/>
+        </p:spPr>
+        <p:txBody>
+          <a:bodyPr wrap="square" lIns="0" tIns="0" rIns="0" bIns="0" rtlCol="0" anchor="ctr"/>
+          <a:lstStyle/>
+          <a:p>
+            <a:pPr indent="0" marL="0">
+              <a:buNone/>
+            </a:pPr>
+            <a:r>
+              <a:rPr lang="en-US" sz="1100" dirty="0">
+                <a:solidFill>
+                  <a:srgbClr val="9BB0C4"/>
+                </a:solidFill>
+                <a:latin typeface="Calibri" pitchFamily="34" charset="0"/>
+                <a:ea typeface="Calibri" pitchFamily="34" charset="-122"/>
+                <a:cs typeface="Calibri" pitchFamily="34" charset="-120"/>
+              </a:rPr>
+              <a:t>después  ·  como predice la teoría</a:t>
+            </a:r>
+            <a:endParaRPr lang="en-US" sz="1100" dirty="0"/>
+          </a:p>
+        </p:txBody>
+      </p:sp>
+      <p:sp>
+        <p:nvSpPr>
+          <p:cNvPr id="26" name="Text 24"/>
+          <p:cNvSpPr/>
+          <p:nvPr/>
+        </p:nvSpPr>
+        <p:spPr>
+          <a:xfrm>
+            <a:off x="8321040" y="4160520"/>
+            <a:ext cx="2926080" cy="1097280"/>
+          </a:xfrm>
+          <a:prstGeom prst="rect">
+            <a:avLst/>
+          </a:prstGeom>
+          <a:noFill/>
+          <a:ln/>
+        </p:spPr>
+        <p:txBody>
+          <a:bodyPr wrap="square" lIns="0" tIns="0" rIns="0" bIns="0" rtlCol="0" anchor="ctr"/>
+          <a:lstStyle/>
+          <a:p>
+            <a:pPr indent="0" marL="0">
               <a:lnSpc>
-                <a:spcPts val="1700"/>
+                <a:spcPts val="1800"/>
               </a:lnSpc>
-              <a:spcAft>
-                <a:spcPts val="1200"/>
-              </a:spcAft>
-              <a:buSzPct val="100000"/>
-              <a:buChar char="•"/>
+              <a:buNone/>
             </a:pPr>
             <a:r>
               <a:rPr lang="en-US" sz="1250" dirty="0">
@@ -12031,52 +10984,7 @@
                 <a:ea typeface="Calibri" pitchFamily="34" charset="-122"/>
                 <a:cs typeface="Calibri" pitchFamily="34" charset="-120"/>
               </a:rPr>
-              <a:t>Round-robin es siempre la más débil del grupo bueno, en las 3 corridas — la localidad de caché sí es un efecto real.</a:t>
-            </a:r>
-            <a:endParaRPr lang="en-US" sz="1250" dirty="0"/>
-          </a:p>
-          <a:p>
-            <a:pPr marL="342900" indent="-342900">
-              <a:lnSpc>
-                <a:spcPts val="1700"/>
-              </a:lnSpc>
-              <a:spcAft>
-                <a:spcPts val="1200"/>
-              </a:spcAft>
-              <a:buSzPct val="100000"/>
-              <a:buChar char="•"/>
-            </a:pPr>
-            <a:r>
-              <a:rPr lang="en-US" sz="1250" dirty="0">
-                <a:solidFill>
-                  <a:srgbClr val="9BB0C4"/>
-                </a:solidFill>
-                <a:latin typeface="Calibri" pitchFamily="34" charset="0"/>
-                <a:ea typeface="Calibri" pitchFamily="34" charset="-122"/>
-                <a:cs typeface="Calibri" pitchFamily="34" charset="-120"/>
-              </a:rPr>
-              <a:t>Sincronizar por fila siempre rinde un orden de magnitud peor. Nunca falló en ninguna corrida.</a:t>
-            </a:r>
-            <a:endParaRPr lang="en-US" sz="1250" dirty="0"/>
-          </a:p>
-          <a:p>
-            <a:pPr marL="342900" indent="-342900">
-              <a:lnSpc>
-                <a:spcPts val="1700"/>
-              </a:lnSpc>
-              <a:buSzPct val="100000"/>
-              <a:buChar char="•"/>
-            </a:pPr>
-            <a:r>
-              <a:rPr lang="en-US" sz="1250" dirty="0">
-                <a:solidFill>
-                  <a:srgbClr val="9BB0C4"/>
-                </a:solidFill>
-                <a:latin typeface="Calibri" pitchFamily="34" charset="0"/>
-                <a:ea typeface="Calibri" pitchFamily="34" charset="-122"/>
-                <a:cs typeface="Calibri" pitchFamily="34" charset="-120"/>
-              </a:rPr>
-              <a:t>Diferencias grandes se ven en cualquier corrida; diferencias finas necesitan promediar.</a:t>
+              <a:t>La solución: calentar todas las estrategias antes de medir ninguna, y reportar el mejor de 3 tiempos.</a:t>
             </a:r>
             <a:endParaRPr lang="en-US" sz="1250" dirty="0"/>
           </a:p>
@@ -12141,13 +11049,13 @@
             <a:r>
               <a:rPr lang="en-US" sz="1200" b="1" spc="200" kern="0" dirty="0">
                 <a:solidFill>
-                  <a:srgbClr val="00A896"/>
-                </a:solidFill>
-                <a:latin typeface="Calibri" pitchFamily="34" charset="0"/>
-                <a:ea typeface="Calibri" pitchFamily="34" charset="-122"/>
-                <a:cs typeface="Calibri" pitchFamily="34" charset="-120"/>
-              </a:rPr>
-              <a:t>LA MEJORA</a:t>
+                  <a:srgbClr val="E94F4F"/>
+                </a:solidFill>
+                <a:latin typeface="Calibri" pitchFamily="34" charset="0"/>
+                <a:ea typeface="Calibri" pitchFamily="34" charset="-122"/>
+                <a:cs typeface="Calibri" pitchFamily="34" charset="-120"/>
+              </a:rPr>
+              <a:t>LA RETRACTACIÓN</a:t>
             </a:r>
             <a:endParaRPr lang="en-US" sz="1200" dirty="0"/>
           </a:p>
@@ -12186,7 +11094,7 @@
                 <a:ea typeface="Cambria" pitchFamily="34" charset="-122"/>
                 <a:cs typeface="Cambria" pitchFamily="34" charset="-120"/>
               </a:rPr>
-              <a:t>Los hilos compartían algo invisible</a:t>
+              <a:t>Una conclusión que se cayó</a:t>
             </a:r>
             <a:endParaRPr lang="en-US" sz="3800" dirty="0"/>
           </a:p>
@@ -12201,7 +11109,7 @@
         <p:spPr>
           <a:xfrm>
             <a:off x="658368" y="1170432"/>
-            <a:ext cx="6949440" cy="822960"/>
+            <a:ext cx="6949440" cy="685800"/>
           </a:xfrm>
           <a:prstGeom prst="rect">
             <a:avLst/>
@@ -12228,7 +11136,7 @@
                 <a:ea typeface="Calibri" pitchFamily="34" charset="-122"/>
                 <a:cs typeface="Calibri" pitchFamily="34" charset="-120"/>
               </a:rPr>
-              <a:t>Ninguna de estas estrategias usa locks entre hilos — pero todas alocan memoria del mismo heap. El recolector de basura por defecto (Workstation GC) pausa a todos los hilos a la vez: es sincronización que no aparece en el código.</a:t>
+              <a:t>Habíamos concluido que activar Server GC mejoraba la eficiencia entre 6 y 32 puntos. Al repetir la comparación con el método corregido, esa mejora desapareció.</a:t>
             </a:r>
             <a:endParaRPr lang="en-US" sz="1400" dirty="0"/>
           </a:p>
@@ -12241,8 +11149,8 @@
           <p:nvPr/>
         </p:nvGraphicFramePr>
         <p:xfrm>
-          <a:off x="640080" y="2103120"/>
-          <a:ext cx="7040880" cy="3520440"/>
+          <a:off x="640080" y="1965960"/>
+          <a:ext cx="7040880" cy="3566160"/>
         </p:xfrm>
         <a:graphic xmlns:a="http://schemas.openxmlformats.org/drawingml/2006/main">
           <a:graphicData uri="http://schemas.openxmlformats.org/drawingml/2006/chart">
@@ -12252,14 +11160,53 @@
       </p:graphicFrame>
       <p:sp>
         <p:nvSpPr>
-          <p:cNvPr id="6" name="Shape 3"/>
-          <p:cNvSpPr/>
-          <p:nvPr/>
-        </p:nvSpPr>
-        <p:spPr>
-          <a:xfrm>
-            <a:off x="8001000" y="1170432"/>
-            <a:ext cx="3547872" cy="4453128"/>
+          <p:cNvPr id="6" name="Text 3"/>
+          <p:cNvSpPr/>
+          <p:nvPr/>
+        </p:nvSpPr>
+        <p:spPr>
+          <a:xfrm>
+            <a:off x="658368" y="5577840"/>
+            <a:ext cx="7040880" cy="274320"/>
+          </a:xfrm>
+          <a:prstGeom prst="rect">
+            <a:avLst/>
+          </a:prstGeom>
+          <a:noFill/>
+          <a:ln/>
+        </p:spPr>
+        <p:txBody>
+          <a:bodyPr wrap="square" lIns="0" tIns="0" rIns="0" bIns="0" rtlCol="0" anchor="ctr"/>
+          <a:lstStyle/>
+          <a:p>
+            <a:pPr indent="0" marL="0">
+              <a:buNone/>
+            </a:pPr>
+            <a:r>
+              <a:rPr lang="en-US" sz="1100" i="1" dirty="0">
+                <a:solidFill>
+                  <a:srgbClr val="5A6B7D"/>
+                </a:solidFill>
+                <a:latin typeface="Calibri" pitchFamily="34" charset="0"/>
+                <a:ea typeface="Calibri" pitchFamily="34" charset="-122"/>
+                <a:cs typeface="Calibri" pitchFamily="34" charset="-120"/>
+              </a:rPr>
+              <a:t>Eficiencia con 8 hilos · 5 M de filas · ambas configuraciones medidas una tras otra</a:t>
+            </a:r>
+            <a:endParaRPr lang="en-US" sz="1100" dirty="0"/>
+          </a:p>
+        </p:txBody>
+      </p:sp>
+      <p:sp>
+        <p:nvSpPr>
+          <p:cNvPr id="7" name="Shape 4"/>
+          <p:cNvSpPr/>
+          <p:nvPr/>
+        </p:nvSpPr>
+        <p:spPr>
+          <a:xfrm>
+            <a:off x="8001000" y="1965960"/>
+            <a:ext cx="3547872" cy="3566160"/>
           </a:xfrm>
           <a:prstGeom prst="roundRect">
             <a:avLst>
@@ -12286,14 +11233,14 @@
       </p:sp>
       <p:sp>
         <p:nvSpPr>
-          <p:cNvPr id="7" name="Text 4"/>
-          <p:cNvSpPr/>
-          <p:nvPr/>
-        </p:nvSpPr>
-        <p:spPr>
-          <a:xfrm>
-            <a:off x="8321040" y="1463040"/>
-            <a:ext cx="2926080" cy="320040"/>
+          <p:cNvPr id="8" name="Text 5"/>
+          <p:cNvSpPr/>
+          <p:nvPr/>
+        </p:nvSpPr>
+        <p:spPr>
+          <a:xfrm>
+            <a:off x="8321040" y="2267712"/>
+            <a:ext cx="2926080" cy="292608"/>
           </a:xfrm>
           <a:prstGeom prst="rect">
             <a:avLst/>
@@ -12317,7 +11264,7 @@
                 <a:ea typeface="Calibri" pitchFamily="34" charset="-122"/>
                 <a:cs typeface="Calibri" pitchFamily="34" charset="-120"/>
               </a:rPr>
-              <a:t>La solución</a:t>
+              <a:t>Por qué no mejora</a:t>
             </a:r>
             <a:endParaRPr lang="en-US" sz="1500" dirty="0"/>
           </a:p>
@@ -12325,123 +11272,14 @@
       </p:sp>
       <p:sp>
         <p:nvSpPr>
-          <p:cNvPr id="8" name="Shape 5"/>
-          <p:cNvSpPr/>
-          <p:nvPr/>
-        </p:nvSpPr>
-        <p:spPr>
-          <a:xfrm>
-            <a:off x="8321040" y="1874520"/>
-            <a:ext cx="2926080" cy="868680"/>
-          </a:xfrm>
-          <a:prstGeom prst="roundRect">
-            <a:avLst>
-              <a:gd name="adj" fmla="val 6316"/>
-            </a:avLst>
-          </a:prstGeom>
-          <a:solidFill>
-            <a:srgbClr val="0B141F"/>
-          </a:solidFill>
-          <a:ln w="12700">
-            <a:solidFill>
-              <a:srgbClr val="2C3E52"/>
-            </a:solidFill>
-            <a:prstDash val="solid"/>
-          </a:ln>
-        </p:spPr>
-      </p:sp>
-      <p:sp>
-        <p:nvSpPr>
           <p:cNvPr id="9" name="Text 6"/>
           <p:cNvSpPr/>
           <p:nvPr/>
         </p:nvSpPr>
         <p:spPr>
           <a:xfrm>
-            <a:off x="8430768" y="1938528"/>
-            <a:ext cx="2743200" cy="749808"/>
-          </a:xfrm>
-          <a:prstGeom prst="rect">
-            <a:avLst/>
-          </a:prstGeom>
-          <a:noFill/>
-          <a:ln/>
-        </p:spPr>
-        <p:txBody>
-          <a:bodyPr wrap="square" lIns="0" tIns="0" rIns="0" bIns="0" rtlCol="0" anchor="ctr"/>
-          <a:lstStyle/>
-          <a:p>
-            <a:pPr indent="0" marL="0">
-              <a:lnSpc>
-                <a:spcPts val="1300"/>
-              </a:lnSpc>
-              <a:buNone/>
-            </a:pPr>
-            <a:r>
-              <a:rPr lang="en-US" sz="1000" dirty="0">
-                <a:solidFill>
-                  <a:srgbClr val="02C39A"/>
-                </a:solidFill>
-                <a:latin typeface="Courier New" pitchFamily="34" charset="0"/>
-                <a:ea typeface="Courier New" pitchFamily="34" charset="-122"/>
-                <a:cs typeface="Courier New" pitchFamily="34" charset="-120"/>
-              </a:rPr>
-              <a:t>&lt;ServerGarbageCollection&gt;</a:t>
-            </a:r>
-            <a:endParaRPr lang="en-US" sz="1000" dirty="0"/>
-          </a:p>
-          <a:p>
-            <a:pPr indent="0" marL="0">
-              <a:lnSpc>
-                <a:spcPts val="1300"/>
-              </a:lnSpc>
-              <a:buNone/>
-            </a:pPr>
-            <a:r>
-              <a:rPr lang="en-US" sz="1000" dirty="0">
-                <a:solidFill>
-                  <a:srgbClr val="02C39A"/>
-                </a:solidFill>
-                <a:latin typeface="Courier New" pitchFamily="34" charset="0"/>
-                <a:ea typeface="Courier New" pitchFamily="34" charset="-122"/>
-                <a:cs typeface="Courier New" pitchFamily="34" charset="-120"/>
-              </a:rPr>
-              <a:t>    true</a:t>
-            </a:r>
-            <a:endParaRPr lang="en-US" sz="1000" dirty="0"/>
-          </a:p>
-          <a:p>
-            <a:pPr indent="0" marL="0">
-              <a:lnSpc>
-                <a:spcPts val="1300"/>
-              </a:lnSpc>
-              <a:buNone/>
-            </a:pPr>
-            <a:r>
-              <a:rPr lang="en-US" sz="1000" dirty="0">
-                <a:solidFill>
-                  <a:srgbClr val="02C39A"/>
-                </a:solidFill>
-                <a:latin typeface="Courier New" pitchFamily="34" charset="0"/>
-                <a:ea typeface="Courier New" pitchFamily="34" charset="-122"/>
-                <a:cs typeface="Courier New" pitchFamily="34" charset="-120"/>
-              </a:rPr>
-              <a:t>&lt;/ServerGarbageCollection&gt;</a:t>
-            </a:r>
-            <a:endParaRPr lang="en-US" sz="1000" dirty="0"/>
-          </a:p>
-        </p:txBody>
-      </p:sp>
-      <p:sp>
-        <p:nvSpPr>
-          <p:cNvPr id="10" name="Text 7"/>
-          <p:cNvSpPr/>
-          <p:nvPr/>
-        </p:nvSpPr>
-        <p:spPr>
-          <a:xfrm>
-            <a:off x="8321040" y="2880360"/>
-            <a:ext cx="2926080" cy="731520"/>
+            <a:off x="8321040" y="2697480"/>
+            <a:ext cx="2926080" cy="1188720"/>
           </a:xfrm>
           <a:prstGeom prst="rect">
             <a:avLst/>
@@ -12468,7 +11306,7 @@
                 <a:ea typeface="Calibri" pitchFamily="34" charset="-122"/>
                 <a:cs typeface="Calibri" pitchFamily="34" charset="-120"/>
               </a:rPr>
-              <a:t>Un heap y un hilo recolector por núcleo, en vez de uno compartido por todos.</a:t>
+              <a:t>Los acumuladores son diminutos: 8 sucursales y 12 productos. La presión sobre el heap es mínima, así que el recolector casi no interviene.</a:t>
             </a:r>
             <a:endParaRPr lang="en-US" sz="1250" dirty="0"/>
           </a:p>
@@ -12476,53 +11314,53 @@
       </p:sp>
       <p:sp>
         <p:nvSpPr>
+          <p:cNvPr id="10" name="Text 7"/>
+          <p:cNvSpPr/>
+          <p:nvPr/>
+        </p:nvSpPr>
+        <p:spPr>
+          <a:xfrm>
+            <a:off x="8321040" y="3977640"/>
+            <a:ext cx="2926080" cy="292608"/>
+          </a:xfrm>
+          <a:prstGeom prst="rect">
+            <a:avLst/>
+          </a:prstGeom>
+          <a:noFill/>
+          <a:ln/>
+        </p:spPr>
+        <p:txBody>
+          <a:bodyPr wrap="square" lIns="0" tIns="0" rIns="0" bIns="0" rtlCol="0" anchor="ctr"/>
+          <a:lstStyle/>
+          <a:p>
+            <a:pPr indent="0" marL="0">
+              <a:buNone/>
+            </a:pPr>
+            <a:r>
+              <a:rPr lang="en-US" sz="1500" b="1" dirty="0">
+                <a:solidFill>
+                  <a:srgbClr val="02C39A"/>
+                </a:solidFill>
+                <a:latin typeface="Calibri" pitchFamily="34" charset="0"/>
+                <a:ea typeface="Calibri" pitchFamily="34" charset="-122"/>
+                <a:cs typeface="Calibri" pitchFamily="34" charset="-120"/>
+              </a:rPr>
+              <a:t>Lo que sí sobrevivió</a:t>
+            </a:r>
+            <a:endParaRPr lang="en-US" sz="1500" dirty="0"/>
+          </a:p>
+        </p:txBody>
+      </p:sp>
+      <p:sp>
+        <p:nvSpPr>
           <p:cNvPr id="11" name="Text 8"/>
           <p:cNvSpPr/>
           <p:nvPr/>
         </p:nvSpPr>
         <p:spPr>
           <a:xfrm>
-            <a:off x="8321040" y="3794760"/>
-            <a:ext cx="2926080" cy="594360"/>
-          </a:xfrm>
-          <a:prstGeom prst="rect">
-            <a:avLst/>
-          </a:prstGeom>
-          <a:noFill/>
-          <a:ln/>
-        </p:spPr>
-        <p:txBody>
-          <a:bodyPr wrap="square" lIns="0" tIns="0" rIns="0" bIns="0" rtlCol="0" anchor="ctr"/>
-          <a:lstStyle/>
-          <a:p>
-            <a:pPr indent="0" marL="0">
-              <a:buNone/>
-            </a:pPr>
-            <a:r>
-              <a:rPr lang="en-US" sz="3400" b="1" dirty="0">
-                <a:solidFill>
-                  <a:srgbClr val="02C39A"/>
-                </a:solidFill>
-                <a:latin typeface="Cambria" pitchFamily="34" charset="0"/>
-                <a:ea typeface="Cambria" pitchFamily="34" charset="-122"/>
-                <a:cs typeface="Cambria" pitchFamily="34" charset="-120"/>
-              </a:rPr>
-              <a:t>+6 a +32</a:t>
-            </a:r>
-            <a:endParaRPr lang="en-US" sz="3400" dirty="0"/>
-          </a:p>
-        </p:txBody>
-      </p:sp>
-      <p:sp>
-        <p:nvSpPr>
-          <p:cNvPr id="12" name="Text 9"/>
-          <p:cNvSpPr/>
-          <p:nvPr/>
-        </p:nvSpPr>
-        <p:spPr>
-          <a:xfrm>
-            <a:off x="8321040" y="4434840"/>
-            <a:ext cx="2926080" cy="914400"/>
+            <a:off x="8321040" y="4389120"/>
+            <a:ext cx="2926080" cy="1005840"/>
           </a:xfrm>
           <a:prstGeom prst="rect">
             <a:avLst/>
@@ -12549,7 +11387,7 @@
                 <a:ea typeface="Calibri" pitchFamily="34" charset="-122"/>
                 <a:cs typeface="Calibri" pitchFamily="34" charset="-120"/>
               </a:rPr>
-              <a:t>puntos porcentuales de eficiencia, en las 5 estrategias y de forma consistente en las 3 corridas.</a:t>
+              <a:t>El ranking entre estrategias: todas se dividían entre el mismo baseline erróneo, así que el error se cancelaba.</a:t>
             </a:r>
             <a:endParaRPr lang="en-US" sz="1250" dirty="0"/>
           </a:p>

</xml_diff>